<commit_message>
docs: align submission diagrams reports and demo with verified process architecture
</commit_message>
<xml_diff>
--- a/docs/part-b/presentation/PartB_Demonstration.pptx
+++ b/docs/part-b/presentation/PartB_Demonstration.pptx
@@ -2,24 +2,24 @@
 <file path=ppt/presentation.xml><?xml version="1.0" encoding="utf-8"?>
 <p:presentation xmlns:p="http://schemas.openxmlformats.org/presentationml/2006/main">
   <p:sldMasterIdLst>
-    <p:sldMasterId xmlns:r="http://schemas.openxmlformats.org/officeDocument/2006/relationships" id="2147483648" r:id="R5421c66e460b495c"/>
+    <p:sldMasterId xmlns:r="http://schemas.openxmlformats.org/officeDocument/2006/relationships" id="2147483648" r:id="Raa04acb65c414761"/>
   </p:sldMasterIdLst>
   <p:notesMasterIdLst>
-    <p:notesMasterId xmlns:r="http://schemas.openxmlformats.org/officeDocument/2006/relationships" r:id="Rd5ffb2564d6a488a"/>
+    <p:notesMasterId xmlns:r="http://schemas.openxmlformats.org/officeDocument/2006/relationships" r:id="R9247de8cc5b149c9"/>
   </p:notesMasterIdLst>
   <p:sldIdLst>
-    <p:sldId xmlns:r="http://schemas.openxmlformats.org/officeDocument/2006/relationships" id="256" r:id="R397da96ffb024bb2"/>
-    <p:sldId xmlns:r="http://schemas.openxmlformats.org/officeDocument/2006/relationships" id="257" r:id="R33fff146ac534493"/>
-    <p:sldId xmlns:r="http://schemas.openxmlformats.org/officeDocument/2006/relationships" id="258" r:id="Raa4c338d31724a1d"/>
-    <p:sldId xmlns:r="http://schemas.openxmlformats.org/officeDocument/2006/relationships" id="259" r:id="Ra8611bb5a3014bd5"/>
-    <p:sldId xmlns:r="http://schemas.openxmlformats.org/officeDocument/2006/relationships" id="260" r:id="Rd03f79292840463b"/>
-    <p:sldId xmlns:r="http://schemas.openxmlformats.org/officeDocument/2006/relationships" id="261" r:id="R4d3578916f884d32"/>
-    <p:sldId xmlns:r="http://schemas.openxmlformats.org/officeDocument/2006/relationships" id="262" r:id="R7f2f14684fb3449c"/>
-    <p:sldId xmlns:r="http://schemas.openxmlformats.org/officeDocument/2006/relationships" id="263" r:id="R7abae74cc1044434"/>
-    <p:sldId xmlns:r="http://schemas.openxmlformats.org/officeDocument/2006/relationships" id="264" r:id="R37609c0e897341c8"/>
-    <p:sldId xmlns:r="http://schemas.openxmlformats.org/officeDocument/2006/relationships" id="265" r:id="Rce423ab258444140"/>
-    <p:sldId xmlns:r="http://schemas.openxmlformats.org/officeDocument/2006/relationships" id="266" r:id="R74a3b4954a9f453a"/>
-    <p:sldId xmlns:r="http://schemas.openxmlformats.org/officeDocument/2006/relationships" id="267" r:id="R4342231384274a2a"/>
+    <p:sldId xmlns:r="http://schemas.openxmlformats.org/officeDocument/2006/relationships" id="256" r:id="R449193f5fe16488c"/>
+    <p:sldId xmlns:r="http://schemas.openxmlformats.org/officeDocument/2006/relationships" id="257" r:id="R505b3c7a5d824a2c"/>
+    <p:sldId xmlns:r="http://schemas.openxmlformats.org/officeDocument/2006/relationships" id="258" r:id="R12e9695dae4b4116"/>
+    <p:sldId xmlns:r="http://schemas.openxmlformats.org/officeDocument/2006/relationships" id="259" r:id="R897a6a56325c4cda"/>
+    <p:sldId xmlns:r="http://schemas.openxmlformats.org/officeDocument/2006/relationships" id="260" r:id="R6f69f534c43f4bd2"/>
+    <p:sldId xmlns:r="http://schemas.openxmlformats.org/officeDocument/2006/relationships" id="261" r:id="R3c77fbae162e4d85"/>
+    <p:sldId xmlns:r="http://schemas.openxmlformats.org/officeDocument/2006/relationships" id="262" r:id="Rb13fe8b1efb14bc3"/>
+    <p:sldId xmlns:r="http://schemas.openxmlformats.org/officeDocument/2006/relationships" id="263" r:id="R906d3df30a1040a9"/>
+    <p:sldId xmlns:r="http://schemas.openxmlformats.org/officeDocument/2006/relationships" id="264" r:id="R480ed8001fd747c2"/>
+    <p:sldId xmlns:r="http://schemas.openxmlformats.org/officeDocument/2006/relationships" id="265" r:id="R8afac8402192442a"/>
+    <p:sldId xmlns:r="http://schemas.openxmlformats.org/officeDocument/2006/relationships" id="266" r:id="R104430e86e264faa"/>
+    <p:sldId xmlns:r="http://schemas.openxmlformats.org/officeDocument/2006/relationships" id="267" r:id="R8fa9e3d2e112440b"/>
   </p:sldIdLst>
   <p:sldSz cx="12192000" cy="6858000"/>
   <p:notesSz cx="6858000" cy="9144000"/>
@@ -603,7 +603,7 @@
           <a:lstStyle xmlns:a="http://schemas.openxmlformats.org/drawingml/2006/main"/>
           <a:p xmlns:a="http://schemas.openxmlformats.org/drawingml/2006/main">
             <a:r>
-              <a:t>展示 core-junit.xml 中对应方法、14 条记录、实际截图与证据 SHA-256。</a:t>
+              <a:t>展示 core-junit.xml 中对应方法、15 条记录、实际截图与证据 SHA-256。</a:t>
             </a:r>
           </a:p>
           <a:p xmlns:a="http://schemas.openxmlformats.org/drawingml/2006/main">
@@ -678,7 +678,7 @@
           <a:lstStyle xmlns:a="http://schemas.openxmlformats.org/drawingml/2006/main"/>
           <a:p xmlns:a="http://schemas.openxmlformats.org/drawingml/2006/main">
             <a:r>
-              <a:t>说明本机启动顺序与对公网部署的独立配置要求；现场仅使用本机服务。</a:t>
+              <a:t>说明workbench.cmd start 统一启动入口与对公网部署的独立配置要求；现场仅使用本机服务。</a:t>
             </a:r>
           </a:p>
           <a:p xmlns:a="http://schemas.openxmlformats.org/drawingml/2006/main">
@@ -1330,7 +1330,7 @@
           <p:cNvPr id="3" name="Title">
             <a:extLst xmlns:a="http://schemas.openxmlformats.org/drawingml/2006/main">
               <a:ext uri="{FF2B5EF4-FFF2-40B4-BE49-F238E27FC236}">
-                <a16:creationId xmlns:a16="http://schemas.microsoft.com/office/drawing/2014/main" id="{77A834EB-AB74-4B0E-A821-6140D2866F67}"/>
+                <a16:creationId xmlns:a16="http://schemas.microsoft.com/office/drawing/2014/main" id="{D907982D-1F06-4F5F-BB29-80162ADD43A4}"/>
               </a:ext>
             </a:extLst>
           </p:cNvPr>
@@ -1559,7 +1559,7 @@
           <p:cNvPr id="2" name="Subtitle">
             <a:extLst xmlns:a="http://schemas.openxmlformats.org/drawingml/2006/main">
               <a:ext uri="{FF2B5EF4-FFF2-40B4-BE49-F238E27FC236}">
-                <a16:creationId xmlns:a16="http://schemas.microsoft.com/office/drawing/2014/main" id="{63A1AE2B-FF57-4BB0-9995-445F205310B5}"/>
+                <a16:creationId xmlns:a16="http://schemas.microsoft.com/office/drawing/2014/main" id="{BB54661C-CA36-4D9F-A579-E309530B5E66}"/>
               </a:ext>
             </a:extLst>
           </p:cNvPr>
@@ -1805,7 +1805,7 @@
           <p:cNvPr id="2" name="Section title">
             <a:extLst xmlns:a="http://schemas.openxmlformats.org/drawingml/2006/main">
               <a:ext uri="{FF2B5EF4-FFF2-40B4-BE49-F238E27FC236}">
-                <a16:creationId xmlns:a16="http://schemas.microsoft.com/office/drawing/2014/main" id="{6D1E3F2F-A364-41AC-9CEC-43A659516547}"/>
+                <a16:creationId xmlns:a16="http://schemas.microsoft.com/office/drawing/2014/main" id="{51F35D29-C0A6-45BD-A8FE-7AD58491CB40}"/>
               </a:ext>
             </a:extLst>
           </p:cNvPr>
@@ -2051,7 +2051,7 @@
           <p:cNvPr id="3" name="Title">
             <a:extLst xmlns:a="http://schemas.openxmlformats.org/drawingml/2006/main">
               <a:ext uri="{FF2B5EF4-FFF2-40B4-BE49-F238E27FC236}">
-                <a16:creationId xmlns:a16="http://schemas.microsoft.com/office/drawing/2014/main" id="{60AE4F5E-07FD-4F94-8FA1-8E87D9D7CB33}"/>
+                <a16:creationId xmlns:a16="http://schemas.microsoft.com/office/drawing/2014/main" id="{BBF7DF0E-C1FC-4745-AC8B-6A15F9890E0B}"/>
               </a:ext>
             </a:extLst>
           </p:cNvPr>
@@ -2280,7 +2280,7 @@
           <p:cNvPr id="2" name="Body">
             <a:extLst xmlns:a="http://schemas.openxmlformats.org/drawingml/2006/main">
               <a:ext uri="{FF2B5EF4-FFF2-40B4-BE49-F238E27FC236}">
-                <a16:creationId xmlns:a16="http://schemas.microsoft.com/office/drawing/2014/main" id="{F52D36DC-F755-45E8-869F-F19BC1468E5A}"/>
+                <a16:creationId xmlns:a16="http://schemas.microsoft.com/office/drawing/2014/main" id="{501225E2-D983-4D6C-8236-4A7D6A670B50}"/>
               </a:ext>
             </a:extLst>
           </p:cNvPr>
@@ -2526,7 +2526,7 @@
           <p:cNvPr id="4" name="Title">
             <a:extLst xmlns:a="http://schemas.openxmlformats.org/drawingml/2006/main">
               <a:ext uri="{FF2B5EF4-FFF2-40B4-BE49-F238E27FC236}">
-                <a16:creationId xmlns:a16="http://schemas.microsoft.com/office/drawing/2014/main" id="{C2117B38-1F7B-4C79-97C7-9074EABBC6A0}"/>
+                <a16:creationId xmlns:a16="http://schemas.microsoft.com/office/drawing/2014/main" id="{40C9D381-7CAB-45E3-99DF-4E7A657628CA}"/>
               </a:ext>
             </a:extLst>
           </p:cNvPr>
@@ -2755,7 +2755,7 @@
           <p:cNvPr id="2" name="Left column">
             <a:extLst xmlns:a="http://schemas.openxmlformats.org/drawingml/2006/main">
               <a:ext uri="{FF2B5EF4-FFF2-40B4-BE49-F238E27FC236}">
-                <a16:creationId xmlns:a16="http://schemas.microsoft.com/office/drawing/2014/main" id="{39EED8EE-C78A-4A31-A5DF-A0829BD2DFF8}"/>
+                <a16:creationId xmlns:a16="http://schemas.microsoft.com/office/drawing/2014/main" id="{960A54BE-739E-4683-B5D8-C45BAC0203ED}"/>
               </a:ext>
             </a:extLst>
           </p:cNvPr>
@@ -2984,7 +2984,7 @@
           <p:cNvPr id="3" name="Right column">
             <a:extLst xmlns:a="http://schemas.openxmlformats.org/drawingml/2006/main">
               <a:ext uri="{FF2B5EF4-FFF2-40B4-BE49-F238E27FC236}">
-                <a16:creationId xmlns:a16="http://schemas.microsoft.com/office/drawing/2014/main" id="{27E156CE-AD35-4199-8B0E-03E2F169EC3B}"/>
+                <a16:creationId xmlns:a16="http://schemas.microsoft.com/office/drawing/2014/main" id="{29C7C1A1-41A1-43E6-9046-246C9FCD1C49}"/>
               </a:ext>
             </a:extLst>
           </p:cNvPr>
@@ -3230,7 +3230,7 @@
           <p:cNvPr id="3" name="Title">
             <a:extLst xmlns:a="http://schemas.openxmlformats.org/drawingml/2006/main">
               <a:ext uri="{FF2B5EF4-FFF2-40B4-BE49-F238E27FC236}">
-                <a16:creationId xmlns:a16="http://schemas.microsoft.com/office/drawing/2014/main" id="{B4F54FC4-9C23-4808-9F15-8DA91F51B59D}"/>
+                <a16:creationId xmlns:a16="http://schemas.microsoft.com/office/drawing/2014/main" id="{111002DB-4C32-4503-8313-12A98213C4FF}"/>
               </a:ext>
             </a:extLst>
           </p:cNvPr>
@@ -3459,7 +3459,7 @@
           <p:cNvPr id="2" name="Left column">
             <a:extLst xmlns:a="http://schemas.openxmlformats.org/drawingml/2006/main">
               <a:ext uri="{FF2B5EF4-FFF2-40B4-BE49-F238E27FC236}">
-                <a16:creationId xmlns:a16="http://schemas.microsoft.com/office/drawing/2014/main" id="{0426FD56-67C8-4D52-8DFF-453F9B4084C4}"/>
+                <a16:creationId xmlns:a16="http://schemas.microsoft.com/office/drawing/2014/main" id="{BDB24540-DCB0-4669-BFE2-FCC825994BF9}"/>
               </a:ext>
             </a:extLst>
           </p:cNvPr>
@@ -3726,12 +3726,12 @@
   </p:cSld>
   <p:clrMap bg1="lt1" tx1="dk1" bg2="lt2" tx2="dk2" accent1="accent1" accent2="accent2" accent3="accent3" accent4="accent4" accent5="accent5" accent6="accent6" hlink="hlink" folHlink="folHlink"/>
   <p:sldLayoutIdLst>
-    <p:sldLayoutId xmlns:r="http://schemas.openxmlformats.org/officeDocument/2006/relationships" id="2147483649" r:id="R101a4cd5fa01437a"/>
-    <p:sldLayoutId xmlns:r="http://schemas.openxmlformats.org/officeDocument/2006/relationships" id="2147483650" r:id="Raef95686574c4db4"/>
-    <p:sldLayoutId xmlns:r="http://schemas.openxmlformats.org/officeDocument/2006/relationships" id="2147483651" r:id="R1602ee157992467b"/>
-    <p:sldLayoutId xmlns:r="http://schemas.openxmlformats.org/officeDocument/2006/relationships" id="2147483652" r:id="R1c309766c34c4932"/>
-    <p:sldLayoutId xmlns:r="http://schemas.openxmlformats.org/officeDocument/2006/relationships" id="2147483653" r:id="R765ead084cda4f5b"/>
-    <p:sldLayoutId xmlns:r="http://schemas.openxmlformats.org/officeDocument/2006/relationships" id="2147483654" r:id="Rd11de29da3b346df"/>
+    <p:sldLayoutId xmlns:r="http://schemas.openxmlformats.org/officeDocument/2006/relationships" id="2147483649" r:id="Rd713efd8eeae4692"/>
+    <p:sldLayoutId xmlns:r="http://schemas.openxmlformats.org/officeDocument/2006/relationships" id="2147483650" r:id="Reeb96ff23a474e76"/>
+    <p:sldLayoutId xmlns:r="http://schemas.openxmlformats.org/officeDocument/2006/relationships" id="2147483651" r:id="R1462cdff525e4d94"/>
+    <p:sldLayoutId xmlns:r="http://schemas.openxmlformats.org/officeDocument/2006/relationships" id="2147483652" r:id="R99b856f83b274c21"/>
+    <p:sldLayoutId xmlns:r="http://schemas.openxmlformats.org/officeDocument/2006/relationships" id="2147483653" r:id="R7feb0710845c4440"/>
+    <p:sldLayoutId xmlns:r="http://schemas.openxmlformats.org/officeDocument/2006/relationships" id="2147483654" r:id="R696ec30733324d96"/>
   </p:sldLayoutIdLst>
   <p:txStyles>
     <p:titleStyle>
@@ -4282,7 +4282,7 @@
           <p:cNvPr id="9" name="">
             <a:extLst xmlns:a="http://schemas.openxmlformats.org/drawingml/2006/main">
               <a:ext uri="{FF2B5EF4-FFF2-40B4-BE49-F238E27FC236}">
-                <a16:creationId xmlns:a16="http://schemas.microsoft.com/office/drawing/2014/main" id="{6832612D-6C95-42AF-B7CB-D19DEBCE9948}"/>
+                <a16:creationId xmlns:a16="http://schemas.microsoft.com/office/drawing/2014/main" id="{E312EFE7-0BE2-4CC0-9434-3E355A69A95A}"/>
               </a:ext>
             </a:extLst>
           </p:cNvPr>
@@ -4313,7 +4313,7 @@
           <p:cNvPr id="2" name="">
             <a:extLst xmlns:a="http://schemas.openxmlformats.org/drawingml/2006/main">
               <a:ext uri="{FF2B5EF4-FFF2-40B4-BE49-F238E27FC236}">
-                <a16:creationId xmlns:a16="http://schemas.microsoft.com/office/drawing/2014/main" id="{BE255256-562A-4461-91D2-3D41E5C2F14A}"/>
+                <a16:creationId xmlns:a16="http://schemas.microsoft.com/office/drawing/2014/main" id="{D330BE57-DCB4-4052-8081-F7AC20A99D85}"/>
               </a:ext>
             </a:extLst>
           </p:cNvPr>
@@ -4344,7 +4344,7 @@
           <p:cNvPr id="3" name="">
             <a:extLst xmlns:a="http://schemas.openxmlformats.org/drawingml/2006/main">
               <a:ext uri="{FF2B5EF4-FFF2-40B4-BE49-F238E27FC236}">
-                <a16:creationId xmlns:a16="http://schemas.microsoft.com/office/drawing/2014/main" id="{8C09B8DE-72EE-4634-8257-233F0B4C1EE8}"/>
+                <a16:creationId xmlns:a16="http://schemas.microsoft.com/office/drawing/2014/main" id="{0087313B-10FE-4EB8-84DA-1932C82E3ED1}"/>
               </a:ext>
             </a:extLst>
           </p:cNvPr>
@@ -4465,7 +4465,7 @@
           <p:cNvPr id="4" name="">
             <a:extLst xmlns:a="http://schemas.openxmlformats.org/drawingml/2006/main">
               <a:ext uri="{FF2B5EF4-FFF2-40B4-BE49-F238E27FC236}">
-                <a16:creationId xmlns:a16="http://schemas.microsoft.com/office/drawing/2014/main" id="{965830EA-94C1-4180-ABA9-49A520B33F9D}"/>
+                <a16:creationId xmlns:a16="http://schemas.microsoft.com/office/drawing/2014/main" id="{07362F2B-BF1B-4283-BA74-858A99F48811}"/>
               </a:ext>
             </a:extLst>
           </p:cNvPr>
@@ -4586,7 +4586,7 @@
           <p:cNvPr id="5" name="">
             <a:extLst xmlns:a="http://schemas.openxmlformats.org/drawingml/2006/main">
               <a:ext uri="{FF2B5EF4-FFF2-40B4-BE49-F238E27FC236}">
-                <a16:creationId xmlns:a16="http://schemas.microsoft.com/office/drawing/2014/main" id="{7F85DD19-5E98-4E5F-AEED-571C9263CBCB}"/>
+                <a16:creationId xmlns:a16="http://schemas.microsoft.com/office/drawing/2014/main" id="{57A428D3-2FDD-42FA-9E82-70AE0BD17D59}"/>
               </a:ext>
             </a:extLst>
           </p:cNvPr>
@@ -4707,7 +4707,7 @@
           <p:cNvPr id="6" name="">
             <a:extLst xmlns:a="http://schemas.openxmlformats.org/drawingml/2006/main">
               <a:ext uri="{FF2B5EF4-FFF2-40B4-BE49-F238E27FC236}">
-                <a16:creationId xmlns:a16="http://schemas.microsoft.com/office/drawing/2014/main" id="{89C39B5A-52FB-43C4-80F4-AA53FBF1027C}"/>
+                <a16:creationId xmlns:a16="http://schemas.microsoft.com/office/drawing/2014/main" id="{BF8250AC-92A0-480A-8E7B-7E0EF4619B69}"/>
               </a:ext>
             </a:extLst>
           </p:cNvPr>
@@ -4738,7 +4738,7 @@
           <p:cNvPr id="7" name="">
             <a:extLst xmlns:a="http://schemas.openxmlformats.org/drawingml/2006/main">
               <a:ext uri="{FF2B5EF4-FFF2-40B4-BE49-F238E27FC236}">
-                <a16:creationId xmlns:a16="http://schemas.microsoft.com/office/drawing/2014/main" id="{ABD8D998-BC69-4460-B2FA-94285C99D02A}"/>
+                <a16:creationId xmlns:a16="http://schemas.microsoft.com/office/drawing/2014/main" id="{1664DD04-808D-45D0-AD86-C4BEA49D5E15}"/>
               </a:ext>
             </a:extLst>
           </p:cNvPr>
@@ -4859,7 +4859,7 @@
           <p:cNvPr id="8" name="">
             <a:extLst xmlns:a="http://schemas.openxmlformats.org/drawingml/2006/main">
               <a:ext uri="{FF2B5EF4-FFF2-40B4-BE49-F238E27FC236}">
-                <a16:creationId xmlns:a16="http://schemas.microsoft.com/office/drawing/2014/main" id="{C5854222-15DF-4A67-9180-24DB60ED8980}"/>
+                <a16:creationId xmlns:a16="http://schemas.microsoft.com/office/drawing/2014/main" id="{7AD3D8E9-E50C-40CD-9CCA-DC29EAD88C55}"/>
               </a:ext>
             </a:extLst>
           </p:cNvPr>
@@ -4978,7 +4978,7 @@
     </p:spTree>
     <p:extLst>
       <p:ext uri="{BB962C8B-B14F-4D97-AF65-F5344CB8AC3E}">
-        <p14:creationId xmlns:p14="http://schemas.microsoft.com/office/powerpoint/2010/main" val="1754226753"/>
+        <p14:creationId xmlns:p14="http://schemas.microsoft.com/office/powerpoint/2010/main" val="657491210"/>
       </p:ext>
     </p:extLst>
   </p:cSld>
@@ -5009,7 +5009,7 @@
           <p:cNvPr id="17" name="">
             <a:extLst xmlns:a="http://schemas.openxmlformats.org/drawingml/2006/main">
               <a:ext uri="{FF2B5EF4-FFF2-40B4-BE49-F238E27FC236}">
-                <a16:creationId xmlns:a16="http://schemas.microsoft.com/office/drawing/2014/main" id="{BE90C38F-970F-47A9-A6BC-17A2475F8CBB}"/>
+                <a16:creationId xmlns:a16="http://schemas.microsoft.com/office/drawing/2014/main" id="{58ADD293-D4E3-4A77-8742-9264647A10B2}"/>
               </a:ext>
             </a:extLst>
           </p:cNvPr>
@@ -5040,7 +5040,7 @@
           <p:cNvPr id="2" name="">
             <a:extLst xmlns:a="http://schemas.openxmlformats.org/drawingml/2006/main">
               <a:ext uri="{FF2B5EF4-FFF2-40B4-BE49-F238E27FC236}">
-                <a16:creationId xmlns:a16="http://schemas.microsoft.com/office/drawing/2014/main" id="{58285D8B-9CB7-4CC0-B578-175EB93F89BC}"/>
+                <a16:creationId xmlns:a16="http://schemas.microsoft.com/office/drawing/2014/main" id="{713C4772-2735-4602-9B4C-851B82CB6323}"/>
               </a:ext>
             </a:extLst>
           </p:cNvPr>
@@ -5161,7 +5161,7 @@
           <p:cNvPr id="3" name="">
             <a:extLst xmlns:a="http://schemas.openxmlformats.org/drawingml/2006/main">
               <a:ext uri="{FF2B5EF4-FFF2-40B4-BE49-F238E27FC236}">
-                <a16:creationId xmlns:a16="http://schemas.microsoft.com/office/drawing/2014/main" id="{4407CCF8-F558-4DD6-BABE-D8B8E5846DC5}"/>
+                <a16:creationId xmlns:a16="http://schemas.microsoft.com/office/drawing/2014/main" id="{075EF8B4-5D8A-405D-B724-4737CEE0A2BB}"/>
               </a:ext>
             </a:extLst>
           </p:cNvPr>
@@ -5282,7 +5282,7 @@
           <p:cNvPr id="4" name="">
             <a:extLst xmlns:a="http://schemas.openxmlformats.org/drawingml/2006/main">
               <a:ext uri="{FF2B5EF4-FFF2-40B4-BE49-F238E27FC236}">
-                <a16:creationId xmlns:a16="http://schemas.microsoft.com/office/drawing/2014/main" id="{5E6C2368-4530-4E20-9890-C01E719563D7}"/>
+                <a16:creationId xmlns:a16="http://schemas.microsoft.com/office/drawing/2014/main" id="{82BE6863-0E05-46D9-BAF7-D0EBEE5B2542}"/>
               </a:ext>
             </a:extLst>
           </p:cNvPr>
@@ -5403,7 +5403,7 @@
           <p:cNvPr id="5" name="">
             <a:extLst xmlns:a="http://schemas.openxmlformats.org/drawingml/2006/main">
               <a:ext uri="{FF2B5EF4-FFF2-40B4-BE49-F238E27FC236}">
-                <a16:creationId xmlns:a16="http://schemas.microsoft.com/office/drawing/2014/main" id="{D8277A34-D289-4AF9-8AA5-F009CE6040A1}"/>
+                <a16:creationId xmlns:a16="http://schemas.microsoft.com/office/drawing/2014/main" id="{9811BA8B-8C7C-41C8-971F-1DBD5BC59812}"/>
               </a:ext>
             </a:extLst>
           </p:cNvPr>
@@ -5434,7 +5434,7 @@
           <p:cNvPr id="6" name="">
             <a:extLst xmlns:a="http://schemas.openxmlformats.org/drawingml/2006/main">
               <a:ext uri="{FF2B5EF4-FFF2-40B4-BE49-F238E27FC236}">
-                <a16:creationId xmlns:a16="http://schemas.microsoft.com/office/drawing/2014/main" id="{FF4498BB-8ACE-477D-9233-01EC4959D9A5}"/>
+                <a16:creationId xmlns:a16="http://schemas.microsoft.com/office/drawing/2014/main" id="{77F9A54C-35C5-4C44-8B29-72BE1646EEE1}"/>
               </a:ext>
             </a:extLst>
           </p:cNvPr>
@@ -5555,7 +5555,7 @@
           <p:cNvPr id="7" name="">
             <a:extLst xmlns:a="http://schemas.openxmlformats.org/drawingml/2006/main">
               <a:ext uri="{FF2B5EF4-FFF2-40B4-BE49-F238E27FC236}">
-                <a16:creationId xmlns:a16="http://schemas.microsoft.com/office/drawing/2014/main" id="{376AD7F5-FF50-4F3B-9D77-EFD48F9E12F9}"/>
+                <a16:creationId xmlns:a16="http://schemas.microsoft.com/office/drawing/2014/main" id="{381D4D29-A98C-416E-B48E-FAD63998B4A4}"/>
               </a:ext>
             </a:extLst>
           </p:cNvPr>
@@ -5565,7 +5565,7 @@
           <p:nvPr/>
         </p:nvPicPr>
         <p:blipFill>
-          <a:blip xmlns:r="http://schemas.openxmlformats.org/officeDocument/2006/relationships" xmlns:a="http://schemas.openxmlformats.org/drawingml/2006/main" r:embed="Rff73e16bf47d462d"/>
+          <a:blip xmlns:r="http://schemas.openxmlformats.org/officeDocument/2006/relationships" xmlns:a="http://schemas.openxmlformats.org/drawingml/2006/main" r:embed="R2e98ddccec3249c4"/>
           <a:stretch xmlns:a="http://schemas.openxmlformats.org/drawingml/2006/main"/>
         </p:blipFill>
         <p:spPr>
@@ -5583,7 +5583,7 @@
           <p:cNvPr id="8" name="">
             <a:extLst xmlns:a="http://schemas.openxmlformats.org/drawingml/2006/main">
               <a:ext uri="{FF2B5EF4-FFF2-40B4-BE49-F238E27FC236}">
-                <a16:creationId xmlns:a16="http://schemas.microsoft.com/office/drawing/2014/main" id="{2A572F2F-ECC2-4509-854A-DC14A88BEF95}"/>
+                <a16:creationId xmlns:a16="http://schemas.microsoft.com/office/drawing/2014/main" id="{A192AC2A-2EC2-4AA7-9999-5D925D14EE17}"/>
               </a:ext>
             </a:extLst>
           </p:cNvPr>
@@ -5614,7 +5614,7 @@
           <p:cNvPr id="9" name="">
             <a:extLst xmlns:a="http://schemas.openxmlformats.org/drawingml/2006/main">
               <a:ext uri="{FF2B5EF4-FFF2-40B4-BE49-F238E27FC236}">
-                <a16:creationId xmlns:a16="http://schemas.microsoft.com/office/drawing/2014/main" id="{677949C5-F16B-4073-AA79-0CA5CE741612}"/>
+                <a16:creationId xmlns:a16="http://schemas.microsoft.com/office/drawing/2014/main" id="{5597A84A-1430-4501-967D-EC41366A2FEB}"/>
               </a:ext>
             </a:extLst>
           </p:cNvPr>
@@ -5735,7 +5735,7 @@
           <p:cNvPr id="10" name="">
             <a:extLst xmlns:a="http://schemas.openxmlformats.org/drawingml/2006/main">
               <a:ext uri="{FF2B5EF4-FFF2-40B4-BE49-F238E27FC236}">
-                <a16:creationId xmlns:a16="http://schemas.microsoft.com/office/drawing/2014/main" id="{8E9ACF92-D843-4F03-A2BF-A0CDD9AAB455}"/>
+                <a16:creationId xmlns:a16="http://schemas.microsoft.com/office/drawing/2014/main" id="{C8250BC6-38B1-4C32-89DD-853647BCC224}"/>
               </a:ext>
             </a:extLst>
           </p:cNvPr>
@@ -5856,7 +5856,7 @@
           <p:cNvPr id="11" name="">
             <a:extLst xmlns:a="http://schemas.openxmlformats.org/drawingml/2006/main">
               <a:ext uri="{FF2B5EF4-FFF2-40B4-BE49-F238E27FC236}">
-                <a16:creationId xmlns:a16="http://schemas.microsoft.com/office/drawing/2014/main" id="{278E5475-C5F3-4813-8F73-E0CAEF350A20}"/>
+                <a16:creationId xmlns:a16="http://schemas.microsoft.com/office/drawing/2014/main" id="{C7C6A429-3B72-4B8B-8016-BB630F7EB73B}"/>
               </a:ext>
             </a:extLst>
           </p:cNvPr>
@@ -5887,7 +5887,7 @@
           <p:cNvPr id="12" name="">
             <a:extLst xmlns:a="http://schemas.openxmlformats.org/drawingml/2006/main">
               <a:ext uri="{FF2B5EF4-FFF2-40B4-BE49-F238E27FC236}">
-                <a16:creationId xmlns:a16="http://schemas.microsoft.com/office/drawing/2014/main" id="{DE6A8194-3324-45E5-881F-77889ACC5634}"/>
+                <a16:creationId xmlns:a16="http://schemas.microsoft.com/office/drawing/2014/main" id="{DEC193E2-E5CE-45C2-A5CD-5ABF5E451809}"/>
               </a:ext>
             </a:extLst>
           </p:cNvPr>
@@ -6008,7 +6008,7 @@
           <p:cNvPr id="13" name="">
             <a:extLst xmlns:a="http://schemas.openxmlformats.org/drawingml/2006/main">
               <a:ext uri="{FF2B5EF4-FFF2-40B4-BE49-F238E27FC236}">
-                <a16:creationId xmlns:a16="http://schemas.microsoft.com/office/drawing/2014/main" id="{53069F3E-BC05-4899-84A3-1156F252759E}"/>
+                <a16:creationId xmlns:a16="http://schemas.microsoft.com/office/drawing/2014/main" id="{F2EBD697-1973-4F70-B4D5-E4E4439D8C0E}"/>
               </a:ext>
             </a:extLst>
           </p:cNvPr>
@@ -6129,7 +6129,7 @@
           <p:cNvPr id="14" name="">
             <a:extLst xmlns:a="http://schemas.openxmlformats.org/drawingml/2006/main">
               <a:ext uri="{FF2B5EF4-FFF2-40B4-BE49-F238E27FC236}">
-                <a16:creationId xmlns:a16="http://schemas.microsoft.com/office/drawing/2014/main" id="{267806F7-069F-4903-9270-6992AA690097}"/>
+                <a16:creationId xmlns:a16="http://schemas.microsoft.com/office/drawing/2014/main" id="{2129D290-8A6B-47E4-AB77-0A135D11C915}"/>
               </a:ext>
             </a:extLst>
           </p:cNvPr>
@@ -6160,7 +6160,7 @@
           <p:cNvPr id="15" name="">
             <a:extLst xmlns:a="http://schemas.openxmlformats.org/drawingml/2006/main">
               <a:ext uri="{FF2B5EF4-FFF2-40B4-BE49-F238E27FC236}">
-                <a16:creationId xmlns:a16="http://schemas.microsoft.com/office/drawing/2014/main" id="{DC4A689E-8AC1-49B3-9C99-20E277C8F749}"/>
+                <a16:creationId xmlns:a16="http://schemas.microsoft.com/office/drawing/2014/main" id="{BC74977C-9B48-4BFB-869C-128F0E5A2739}"/>
               </a:ext>
             </a:extLst>
           </p:cNvPr>
@@ -6271,7 +6271,7 @@
                   <a:srgbClr val="102A38"/>
                 </a:solidFill>
               </a:rPr>
-              <a:t>验签状态</a:t>
+              <a:t>504 / 验签状态</a:t>
             </a:r>
           </a:p>
         </p:txBody>
@@ -6281,7 +6281,7 @@
           <p:cNvPr id="16" name="">
             <a:extLst xmlns:a="http://schemas.openxmlformats.org/drawingml/2006/main">
               <a:ext uri="{FF2B5EF4-FFF2-40B4-BE49-F238E27FC236}">
-                <a16:creationId xmlns:a16="http://schemas.microsoft.com/office/drawing/2014/main" id="{5F336E4B-8321-46D6-A604-F795D2853FDC}"/>
+                <a16:creationId xmlns:a16="http://schemas.microsoft.com/office/drawing/2014/main" id="{C8BBBFAA-2395-47F8-ACC9-9461F0D36799}"/>
               </a:ext>
             </a:extLst>
           </p:cNvPr>
@@ -6392,7 +6392,7 @@
                   <a:srgbClr val="5C6C70"/>
                 </a:solidFill>
               </a:rPr>
-              <a:t>无法判定修订，不等于请求失败。</a:t>
+              <a:t>处理超时；验签结论单独呈现。</a:t>
             </a:r>
           </a:p>
         </p:txBody>
@@ -6400,7 +6400,7 @@
     </p:spTree>
     <p:extLst>
       <p:ext uri="{BB962C8B-B14F-4D97-AF65-F5344CB8AC3E}">
-        <p14:creationId xmlns:p14="http://schemas.microsoft.com/office/powerpoint/2010/main" val="781809204"/>
+        <p14:creationId xmlns:p14="http://schemas.microsoft.com/office/powerpoint/2010/main" val="1386023328"/>
       </p:ext>
     </p:extLst>
   </p:cSld>
@@ -6431,7 +6431,7 @@
           <p:cNvPr id="14" name="">
             <a:extLst xmlns:a="http://schemas.openxmlformats.org/drawingml/2006/main">
               <a:ext uri="{FF2B5EF4-FFF2-40B4-BE49-F238E27FC236}">
-                <a16:creationId xmlns:a16="http://schemas.microsoft.com/office/drawing/2014/main" id="{722528D1-B53A-4845-88F8-0C42ECD7FBB0}"/>
+                <a16:creationId xmlns:a16="http://schemas.microsoft.com/office/drawing/2014/main" id="{52B7D779-B49C-4FF5-9911-78514D2EB50D}"/>
               </a:ext>
             </a:extLst>
           </p:cNvPr>
@@ -6462,7 +6462,7 @@
           <p:cNvPr id="2" name="">
             <a:extLst xmlns:a="http://schemas.openxmlformats.org/drawingml/2006/main">
               <a:ext uri="{FF2B5EF4-FFF2-40B4-BE49-F238E27FC236}">
-                <a16:creationId xmlns:a16="http://schemas.microsoft.com/office/drawing/2014/main" id="{4F6336EC-136A-406C-8534-84184E1B3F85}"/>
+                <a16:creationId xmlns:a16="http://schemas.microsoft.com/office/drawing/2014/main" id="{860B9765-EB2C-4CE2-A5A1-9E7172F0250E}"/>
               </a:ext>
             </a:extLst>
           </p:cNvPr>
@@ -6583,7 +6583,7 @@
           <p:cNvPr id="3" name="">
             <a:extLst xmlns:a="http://schemas.openxmlformats.org/drawingml/2006/main">
               <a:ext uri="{FF2B5EF4-FFF2-40B4-BE49-F238E27FC236}">
-                <a16:creationId xmlns:a16="http://schemas.microsoft.com/office/drawing/2014/main" id="{76C9ECD4-D44A-4A4A-8E2C-580449CD4D07}"/>
+                <a16:creationId xmlns:a16="http://schemas.microsoft.com/office/drawing/2014/main" id="{0C729831-297F-442A-954F-05DDB1BFE776}"/>
               </a:ext>
             </a:extLst>
           </p:cNvPr>
@@ -6704,7 +6704,7 @@
           <p:cNvPr id="4" name="">
             <a:extLst xmlns:a="http://schemas.openxmlformats.org/drawingml/2006/main">
               <a:ext uri="{FF2B5EF4-FFF2-40B4-BE49-F238E27FC236}">
-                <a16:creationId xmlns:a16="http://schemas.microsoft.com/office/drawing/2014/main" id="{7893ABD9-F582-4D1C-8560-8C0383E7150F}"/>
+                <a16:creationId xmlns:a16="http://schemas.microsoft.com/office/drawing/2014/main" id="{37B84E13-953C-42D8-AA79-4922283CA215}"/>
               </a:ext>
             </a:extLst>
           </p:cNvPr>
@@ -6825,7 +6825,7 @@
           <p:cNvPr id="5" name="">
             <a:extLst xmlns:a="http://schemas.openxmlformats.org/drawingml/2006/main">
               <a:ext uri="{FF2B5EF4-FFF2-40B4-BE49-F238E27FC236}">
-                <a16:creationId xmlns:a16="http://schemas.microsoft.com/office/drawing/2014/main" id="{6EFE4A96-81DF-453D-BC81-8848F71F821C}"/>
+                <a16:creationId xmlns:a16="http://schemas.microsoft.com/office/drawing/2014/main" id="{22F3A3B2-AD22-451C-91B7-968928A42EDC}"/>
               </a:ext>
             </a:extLst>
           </p:cNvPr>
@@ -6856,7 +6856,7 @@
           <p:cNvPr id="6" name="">
             <a:extLst xmlns:a="http://schemas.openxmlformats.org/drawingml/2006/main">
               <a:ext uri="{FF2B5EF4-FFF2-40B4-BE49-F238E27FC236}">
-                <a16:creationId xmlns:a16="http://schemas.microsoft.com/office/drawing/2014/main" id="{0FC1A965-2F2C-455C-8196-65381CF2A741}"/>
+                <a16:creationId xmlns:a16="http://schemas.microsoft.com/office/drawing/2014/main" id="{AA58C10A-468E-4EDE-8465-8430B61CE380}"/>
               </a:ext>
             </a:extLst>
           </p:cNvPr>
@@ -6977,7 +6977,7 @@
           <p:cNvPr id="7" name="">
             <a:extLst xmlns:a="http://schemas.openxmlformats.org/drawingml/2006/main">
               <a:ext uri="{FF2B5EF4-FFF2-40B4-BE49-F238E27FC236}">
-                <a16:creationId xmlns:a16="http://schemas.microsoft.com/office/drawing/2014/main" id="{95D13325-8DF1-4C5A-A754-CC3F517F38E6}"/>
+                <a16:creationId xmlns:a16="http://schemas.microsoft.com/office/drawing/2014/main" id="{1930939C-EF7D-42B5-9C5F-166CE2BF5B5D}"/>
               </a:ext>
             </a:extLst>
           </p:cNvPr>
@@ -7008,7 +7008,7 @@
           <p:cNvPr id="8" name="">
             <a:extLst xmlns:a="http://schemas.openxmlformats.org/drawingml/2006/main">
               <a:ext uri="{FF2B5EF4-FFF2-40B4-BE49-F238E27FC236}">
-                <a16:creationId xmlns:a16="http://schemas.microsoft.com/office/drawing/2014/main" id="{8C4CF34E-461F-4310-A451-37C428EE0C1D}"/>
+                <a16:creationId xmlns:a16="http://schemas.microsoft.com/office/drawing/2014/main" id="{6177BC24-E238-42E5-ACCA-14834B9B42CE}"/>
               </a:ext>
             </a:extLst>
           </p:cNvPr>
@@ -7039,7 +7039,7 @@
           <p:cNvPr id="9" name="">
             <a:extLst xmlns:a="http://schemas.openxmlformats.org/drawingml/2006/main">
               <a:ext uri="{FF2B5EF4-FFF2-40B4-BE49-F238E27FC236}">
-                <a16:creationId xmlns:a16="http://schemas.microsoft.com/office/drawing/2014/main" id="{E2E9FBBC-6E22-4047-817A-310BF347A614}"/>
+                <a16:creationId xmlns:a16="http://schemas.microsoft.com/office/drawing/2014/main" id="{4565520E-17B4-4421-9C45-07D43160EA51}"/>
               </a:ext>
             </a:extLst>
           </p:cNvPr>
@@ -7160,7 +7160,7 @@
           <p:cNvPr id="10" name="">
             <a:extLst xmlns:a="http://schemas.openxmlformats.org/drawingml/2006/main">
               <a:ext uri="{FF2B5EF4-FFF2-40B4-BE49-F238E27FC236}">
-                <a16:creationId xmlns:a16="http://schemas.microsoft.com/office/drawing/2014/main" id="{9170FFCE-224B-4D36-AFFC-8BB249C58DF2}"/>
+                <a16:creationId xmlns:a16="http://schemas.microsoft.com/office/drawing/2014/main" id="{DB99A5F9-0C05-4E9B-BA86-6043DE8F9322}"/>
               </a:ext>
             </a:extLst>
           </p:cNvPr>
@@ -7281,7 +7281,7 @@
           <p:cNvPr id="11" name="">
             <a:extLst xmlns:a="http://schemas.openxmlformats.org/drawingml/2006/main">
               <a:ext uri="{FF2B5EF4-FFF2-40B4-BE49-F238E27FC236}">
-                <a16:creationId xmlns:a16="http://schemas.microsoft.com/office/drawing/2014/main" id="{0B582D83-7933-4444-9F5C-815CC9D8AA7B}"/>
+                <a16:creationId xmlns:a16="http://schemas.microsoft.com/office/drawing/2014/main" id="{50790ED8-14F5-464D-B4A8-BE03B4ED0EFD}"/>
               </a:ext>
             </a:extLst>
           </p:cNvPr>
@@ -7402,7 +7402,7 @@
           <p:cNvPr id="12" name="">
             <a:extLst xmlns:a="http://schemas.openxmlformats.org/drawingml/2006/main">
               <a:ext uri="{FF2B5EF4-FFF2-40B4-BE49-F238E27FC236}">
-                <a16:creationId xmlns:a16="http://schemas.microsoft.com/office/drawing/2014/main" id="{23CCDDDD-F119-4063-BA29-2081E829D835}"/>
+                <a16:creationId xmlns:a16="http://schemas.microsoft.com/office/drawing/2014/main" id="{6C7B57DA-B3BC-4B2E-92FC-6455E43A1479}"/>
               </a:ext>
             </a:extLst>
           </p:cNvPr>
@@ -7523,7 +7523,7 @@
           <p:cNvPr id="13" name="">
             <a:extLst xmlns:a="http://schemas.openxmlformats.org/drawingml/2006/main">
               <a:ext uri="{FF2B5EF4-FFF2-40B4-BE49-F238E27FC236}">
-                <a16:creationId xmlns:a16="http://schemas.microsoft.com/office/drawing/2014/main" id="{6BC95367-EAAD-4A1B-83A5-524456C73F48}"/>
+                <a16:creationId xmlns:a16="http://schemas.microsoft.com/office/drawing/2014/main" id="{8B59E46F-AEB7-421F-B94B-126FDB729477}"/>
               </a:ext>
             </a:extLst>
           </p:cNvPr>
@@ -7634,7 +7634,7 @@
                   <a:srgbClr val="FFFFFF"/>
                 </a:solidFill>
               </a:rPr>
-              <a:t>14 条完整测试记录  /  需求 → 实现 → 用例 → 证据</a:t>
+              <a:t>15 条完整测试记录  /  需求 → 实现 → 用例 → 证据</a:t>
             </a:r>
           </a:p>
         </p:txBody>
@@ -7642,7 +7642,7 @@
     </p:spTree>
     <p:extLst>
       <p:ext uri="{BB962C8B-B14F-4D97-AF65-F5344CB8AC3E}">
-        <p14:creationId xmlns:p14="http://schemas.microsoft.com/office/powerpoint/2010/main" val="1922021385"/>
+        <p14:creationId xmlns:p14="http://schemas.microsoft.com/office/powerpoint/2010/main" val="1714870529"/>
       </p:ext>
     </p:extLst>
   </p:cSld>
@@ -7670,10 +7670,10 @@
       </p:grpSpPr>
       <p:sp>
         <p:nvSpPr>
-          <p:cNvPr id="25" name="">
+          <p:cNvPr id="26" name="">
             <a:extLst xmlns:a="http://schemas.openxmlformats.org/drawingml/2006/main">
               <a:ext uri="{FF2B5EF4-FFF2-40B4-BE49-F238E27FC236}">
-                <a16:creationId xmlns:a16="http://schemas.microsoft.com/office/drawing/2014/main" id="{4099EE19-DB24-4CEE-B8F5-266633DE97BF}"/>
+                <a16:creationId xmlns:a16="http://schemas.microsoft.com/office/drawing/2014/main" id="{4B056F81-D928-4658-BA0A-24DCA740FA85}"/>
               </a:ext>
             </a:extLst>
           </p:cNvPr>
@@ -7704,7 +7704,7 @@
           <p:cNvPr id="2" name="">
             <a:extLst xmlns:a="http://schemas.openxmlformats.org/drawingml/2006/main">
               <a:ext uri="{FF2B5EF4-FFF2-40B4-BE49-F238E27FC236}">
-                <a16:creationId xmlns:a16="http://schemas.microsoft.com/office/drawing/2014/main" id="{61D12F71-4752-4E18-A2CD-79750BB05F09}"/>
+                <a16:creationId xmlns:a16="http://schemas.microsoft.com/office/drawing/2014/main" id="{0F07A8B9-274B-49E6-9C3E-BD73C6CA2373}"/>
               </a:ext>
             </a:extLst>
           </p:cNvPr>
@@ -7825,7 +7825,7 @@
           <p:cNvPr id="3" name="">
             <a:extLst xmlns:a="http://schemas.openxmlformats.org/drawingml/2006/main">
               <a:ext uri="{FF2B5EF4-FFF2-40B4-BE49-F238E27FC236}">
-                <a16:creationId xmlns:a16="http://schemas.microsoft.com/office/drawing/2014/main" id="{01466280-124D-4059-95C3-C5C8642C3BD3}"/>
+                <a16:creationId xmlns:a16="http://schemas.microsoft.com/office/drawing/2014/main" id="{D877047E-B628-4F51-87A1-C81E6DFCFF6A}"/>
               </a:ext>
             </a:extLst>
           </p:cNvPr>
@@ -7946,7 +7946,7 @@
           <p:cNvPr id="4" name="">
             <a:extLst xmlns:a="http://schemas.openxmlformats.org/drawingml/2006/main">
               <a:ext uri="{FF2B5EF4-FFF2-40B4-BE49-F238E27FC236}">
-                <a16:creationId xmlns:a16="http://schemas.microsoft.com/office/drawing/2014/main" id="{070E9225-8859-47F9-8F7F-167ACF6866A6}"/>
+                <a16:creationId xmlns:a16="http://schemas.microsoft.com/office/drawing/2014/main" id="{2F22462D-F9DA-4CE1-AC28-00C611940605}"/>
               </a:ext>
             </a:extLst>
           </p:cNvPr>
@@ -8067,7 +8067,7 @@
           <p:cNvPr id="5" name="">
             <a:extLst xmlns:a="http://schemas.openxmlformats.org/drawingml/2006/main">
               <a:ext uri="{FF2B5EF4-FFF2-40B4-BE49-F238E27FC236}">
-                <a16:creationId xmlns:a16="http://schemas.microsoft.com/office/drawing/2014/main" id="{59B4B815-B7C5-4261-8D39-4597E6013BBE}"/>
+                <a16:creationId xmlns:a16="http://schemas.microsoft.com/office/drawing/2014/main" id="{024147FC-4992-4A34-B007-1E2EC41D05C2}"/>
               </a:ext>
             </a:extLst>
           </p:cNvPr>
@@ -8098,7 +8098,7 @@
           <p:cNvPr id="6" name="">
             <a:extLst xmlns:a="http://schemas.openxmlformats.org/drawingml/2006/main">
               <a:ext uri="{FF2B5EF4-FFF2-40B4-BE49-F238E27FC236}">
-                <a16:creationId xmlns:a16="http://schemas.microsoft.com/office/drawing/2014/main" id="{607E7BB6-C100-4FF2-A13C-E028EA5F91FC}"/>
+                <a16:creationId xmlns:a16="http://schemas.microsoft.com/office/drawing/2014/main" id="{620280B4-56F5-4A56-9A26-163B2FA8C710}"/>
               </a:ext>
             </a:extLst>
           </p:cNvPr>
@@ -8219,7 +8219,7 @@
           <p:cNvPr id="7" name="">
             <a:extLst xmlns:a="http://schemas.openxmlformats.org/drawingml/2006/main">
               <a:ext uri="{FF2B5EF4-FFF2-40B4-BE49-F238E27FC236}">
-                <a16:creationId xmlns:a16="http://schemas.microsoft.com/office/drawing/2014/main" id="{8F71B309-A900-4AB6-9BC7-028EC671D059}"/>
+                <a16:creationId xmlns:a16="http://schemas.microsoft.com/office/drawing/2014/main" id="{8F3286EA-BF7E-4300-87D6-F5B81AE89341}"/>
               </a:ext>
             </a:extLst>
           </p:cNvPr>
@@ -8250,7 +8250,7 @@
           <p:cNvPr id="8" name="">
             <a:extLst xmlns:a="http://schemas.openxmlformats.org/drawingml/2006/main">
               <a:ext uri="{FF2B5EF4-FFF2-40B4-BE49-F238E27FC236}">
-                <a16:creationId xmlns:a16="http://schemas.microsoft.com/office/drawing/2014/main" id="{616186A2-CC8B-4B40-9885-0042FA2A0D19}"/>
+                <a16:creationId xmlns:a16="http://schemas.microsoft.com/office/drawing/2014/main" id="{C0B5441F-2BE1-4F0C-88E5-745E1AECB93A}"/>
               </a:ext>
             </a:extLst>
           </p:cNvPr>
@@ -8281,7 +8281,7 @@
           <p:cNvPr id="9" name="">
             <a:extLst xmlns:a="http://schemas.openxmlformats.org/drawingml/2006/main">
               <a:ext uri="{FF2B5EF4-FFF2-40B4-BE49-F238E27FC236}">
-                <a16:creationId xmlns:a16="http://schemas.microsoft.com/office/drawing/2014/main" id="{877C2FBE-6598-41B7-AD1C-7F602FAAE375}"/>
+                <a16:creationId xmlns:a16="http://schemas.microsoft.com/office/drawing/2014/main" id="{0169C99F-D4B1-48C7-8EC9-2DCFE669087D}"/>
               </a:ext>
             </a:extLst>
           </p:cNvPr>
@@ -8402,7 +8402,7 @@
           <p:cNvPr id="10" name="">
             <a:extLst xmlns:a="http://schemas.openxmlformats.org/drawingml/2006/main">
               <a:ext uri="{FF2B5EF4-FFF2-40B4-BE49-F238E27FC236}">
-                <a16:creationId xmlns:a16="http://schemas.microsoft.com/office/drawing/2014/main" id="{4810E534-0050-4380-9DAE-06BAEF33AAD9}"/>
+                <a16:creationId xmlns:a16="http://schemas.microsoft.com/office/drawing/2014/main" id="{8C5D65C4-896B-4297-B084-DB9773A84919}"/>
               </a:ext>
             </a:extLst>
           </p:cNvPr>
@@ -8523,7 +8523,7 @@
           <p:cNvPr id="11" name="">
             <a:extLst xmlns:a="http://schemas.openxmlformats.org/drawingml/2006/main">
               <a:ext uri="{FF2B5EF4-FFF2-40B4-BE49-F238E27FC236}">
-                <a16:creationId xmlns:a16="http://schemas.microsoft.com/office/drawing/2014/main" id="{CD5CD89C-90A4-433E-853F-C63D508044DF}"/>
+                <a16:creationId xmlns:a16="http://schemas.microsoft.com/office/drawing/2014/main" id="{888027E9-F39D-404D-9DD0-7E630CDE5DB6}"/>
               </a:ext>
             </a:extLst>
           </p:cNvPr>
@@ -8554,7 +8554,7 @@
           <p:cNvPr id="12" name="">
             <a:extLst xmlns:a="http://schemas.openxmlformats.org/drawingml/2006/main">
               <a:ext uri="{FF2B5EF4-FFF2-40B4-BE49-F238E27FC236}">
-                <a16:creationId xmlns:a16="http://schemas.microsoft.com/office/drawing/2014/main" id="{A7BAEE90-DF97-490A-A34A-B9E4F804B4EF}"/>
+                <a16:creationId xmlns:a16="http://schemas.microsoft.com/office/drawing/2014/main" id="{AB185982-3A02-437D-A545-A94AD9517053}"/>
               </a:ext>
             </a:extLst>
           </p:cNvPr>
@@ -8585,7 +8585,7 @@
           <p:cNvPr id="13" name="">
             <a:extLst xmlns:a="http://schemas.openxmlformats.org/drawingml/2006/main">
               <a:ext uri="{FF2B5EF4-FFF2-40B4-BE49-F238E27FC236}">
-                <a16:creationId xmlns:a16="http://schemas.microsoft.com/office/drawing/2014/main" id="{C59C3C95-DA22-41AD-A490-5CE84B26B65E}"/>
+                <a16:creationId xmlns:a16="http://schemas.microsoft.com/office/drawing/2014/main" id="{97B388DA-CEEC-40F4-953C-3C463173E1C1}"/>
               </a:ext>
             </a:extLst>
           </p:cNvPr>
@@ -8706,7 +8706,7 @@
           <p:cNvPr id="14" name="">
             <a:extLst xmlns:a="http://schemas.openxmlformats.org/drawingml/2006/main">
               <a:ext uri="{FF2B5EF4-FFF2-40B4-BE49-F238E27FC236}">
-                <a16:creationId xmlns:a16="http://schemas.microsoft.com/office/drawing/2014/main" id="{4226B4E9-CD7E-4D8F-8085-EB4D288AA297}"/>
+                <a16:creationId xmlns:a16="http://schemas.microsoft.com/office/drawing/2014/main" id="{8508FA8A-4326-4792-8F80-AE4604315473}"/>
               </a:ext>
             </a:extLst>
           </p:cNvPr>
@@ -8827,7 +8827,7 @@
           <p:cNvPr id="15" name="">
             <a:extLst xmlns:a="http://schemas.openxmlformats.org/drawingml/2006/main">
               <a:ext uri="{FF2B5EF4-FFF2-40B4-BE49-F238E27FC236}">
-                <a16:creationId xmlns:a16="http://schemas.microsoft.com/office/drawing/2014/main" id="{3C51E40B-F649-4ADC-BA64-C28C312DC24A}"/>
+                <a16:creationId xmlns:a16="http://schemas.microsoft.com/office/drawing/2014/main" id="{21DE8AB0-3355-4419-95D1-EED2C74D88AF}"/>
               </a:ext>
             </a:extLst>
           </p:cNvPr>
@@ -8858,7 +8858,7 @@
           <p:cNvPr id="16" name="">
             <a:extLst xmlns:a="http://schemas.openxmlformats.org/drawingml/2006/main">
               <a:ext uri="{FF2B5EF4-FFF2-40B4-BE49-F238E27FC236}">
-                <a16:creationId xmlns:a16="http://schemas.microsoft.com/office/drawing/2014/main" id="{60E5DC20-1D6F-4257-BA79-7A14BC424CF4}"/>
+                <a16:creationId xmlns:a16="http://schemas.microsoft.com/office/drawing/2014/main" id="{F94800E7-0143-4B89-AC2D-42CC4109B795}"/>
               </a:ext>
             </a:extLst>
           </p:cNvPr>
@@ -8889,7 +8889,7 @@
           <p:cNvPr id="17" name="">
             <a:extLst xmlns:a="http://schemas.openxmlformats.org/drawingml/2006/main">
               <a:ext uri="{FF2B5EF4-FFF2-40B4-BE49-F238E27FC236}">
-                <a16:creationId xmlns:a16="http://schemas.microsoft.com/office/drawing/2014/main" id="{823C5B49-2F47-40BA-AB7E-EB2878C7D43F}"/>
+                <a16:creationId xmlns:a16="http://schemas.microsoft.com/office/drawing/2014/main" id="{F9B4CE5D-7822-479F-A294-03CABF1B8E75}"/>
               </a:ext>
             </a:extLst>
           </p:cNvPr>
@@ -9010,7 +9010,7 @@
           <p:cNvPr id="18" name="">
             <a:extLst xmlns:a="http://schemas.openxmlformats.org/drawingml/2006/main">
               <a:ext uri="{FF2B5EF4-FFF2-40B4-BE49-F238E27FC236}">
-                <a16:creationId xmlns:a16="http://schemas.microsoft.com/office/drawing/2014/main" id="{2C132341-EAAE-43EF-B0CF-86D304CC3287}"/>
+                <a16:creationId xmlns:a16="http://schemas.microsoft.com/office/drawing/2014/main" id="{322910B8-3BB2-4792-B03A-816BA4A7B737}"/>
               </a:ext>
             </a:extLst>
           </p:cNvPr>
@@ -9131,7 +9131,7 @@
           <p:cNvPr id="19" name="">
             <a:extLst xmlns:a="http://schemas.openxmlformats.org/drawingml/2006/main">
               <a:ext uri="{FF2B5EF4-FFF2-40B4-BE49-F238E27FC236}">
-                <a16:creationId xmlns:a16="http://schemas.microsoft.com/office/drawing/2014/main" id="{6812FAEF-3DF6-4B81-935E-8766EAFC3168}"/>
+                <a16:creationId xmlns:a16="http://schemas.microsoft.com/office/drawing/2014/main" id="{10CFAFFB-F29A-40E0-9A3A-50C1B843E1F4}"/>
               </a:ext>
             </a:extLst>
           </p:cNvPr>
@@ -9162,7 +9162,7 @@
           <p:cNvPr id="20" name="">
             <a:extLst xmlns:a="http://schemas.openxmlformats.org/drawingml/2006/main">
               <a:ext uri="{FF2B5EF4-FFF2-40B4-BE49-F238E27FC236}">
-                <a16:creationId xmlns:a16="http://schemas.microsoft.com/office/drawing/2014/main" id="{2C9998B4-45D0-4EA7-ABA5-608A2DC5C40F}"/>
+                <a16:creationId xmlns:a16="http://schemas.microsoft.com/office/drawing/2014/main" id="{26565AAE-33C8-4444-B816-5A29F3359C3A}"/>
               </a:ext>
             </a:extLst>
           </p:cNvPr>
@@ -9193,7 +9193,7 @@
           <p:cNvPr id="21" name="">
             <a:extLst xmlns:a="http://schemas.openxmlformats.org/drawingml/2006/main">
               <a:ext uri="{FF2B5EF4-FFF2-40B4-BE49-F238E27FC236}">
-                <a16:creationId xmlns:a16="http://schemas.microsoft.com/office/drawing/2014/main" id="{C86F0A34-62AB-48C0-880E-AA0863107A88}"/>
+                <a16:creationId xmlns:a16="http://schemas.microsoft.com/office/drawing/2014/main" id="{EE0D75E2-7DEE-4AB6-969B-32FD8E241C29}"/>
               </a:ext>
             </a:extLst>
           </p:cNvPr>
@@ -9314,7 +9314,7 @@
           <p:cNvPr id="22" name="">
             <a:extLst xmlns:a="http://schemas.openxmlformats.org/drawingml/2006/main">
               <a:ext uri="{FF2B5EF4-FFF2-40B4-BE49-F238E27FC236}">
-                <a16:creationId xmlns:a16="http://schemas.microsoft.com/office/drawing/2014/main" id="{FD1C71EB-2870-4077-BA8F-CF809C402F73}"/>
+                <a16:creationId xmlns:a16="http://schemas.microsoft.com/office/drawing/2014/main" id="{84A7D488-C27D-4BA8-AC3E-FFD6E9032A87}"/>
               </a:ext>
             </a:extLst>
           </p:cNvPr>
@@ -9435,7 +9435,7 @@
           <p:cNvPr id="23" name="">
             <a:extLst xmlns:a="http://schemas.openxmlformats.org/drawingml/2006/main">
               <a:ext uri="{FF2B5EF4-FFF2-40B4-BE49-F238E27FC236}">
-                <a16:creationId xmlns:a16="http://schemas.microsoft.com/office/drawing/2014/main" id="{BBD3FB13-CA92-4336-BCA9-29A4B7344B14}"/>
+                <a16:creationId xmlns:a16="http://schemas.microsoft.com/office/drawing/2014/main" id="{02048950-68F2-407B-995F-2E03F8A58FDB}"/>
               </a:ext>
             </a:extLst>
           </p:cNvPr>
@@ -9556,7 +9556,7 @@
           <p:cNvPr id="24" name="">
             <a:extLst xmlns:a="http://schemas.openxmlformats.org/drawingml/2006/main">
               <a:ext uri="{FF2B5EF4-FFF2-40B4-BE49-F238E27FC236}">
-                <a16:creationId xmlns:a16="http://schemas.microsoft.com/office/drawing/2014/main" id="{8A9F7D57-C263-4F27-BEE3-4713F776A9A3}"/>
+                <a16:creationId xmlns:a16="http://schemas.microsoft.com/office/drawing/2014/main" id="{545DE3BE-7CF2-426B-BD08-CFC8B4104F72}"/>
               </a:ext>
             </a:extLst>
           </p:cNvPr>
@@ -9567,8 +9567,8 @@
         </p:nvSpPr>
         <p:spPr>
           <a:xfrm xmlns:a="http://schemas.openxmlformats.org/drawingml/2006/main">
-            <a:off x="781050" y="5734050"/>
-            <a:ext cx="10572750" cy="428625"/>
+            <a:off x="781050" y="5695950"/>
+            <a:ext cx="10572750" cy="333375"/>
           </a:xfrm>
           <a:prstGeom xmlns:a="http://schemas.openxmlformats.org/drawingml/2006/main" prst="rect">
             <a:avLst/>
@@ -9583,99 +9583,220 @@
           <a:bodyPr xmlns:a="http://schemas.openxmlformats.org/drawingml/2006/main" lIns="0" tIns="0" rIns="0" bIns="0"/>
           <a:lstStyle xmlns:a="http://schemas.openxmlformats.org/drawingml/2006/main">
             <a:defPPr>
-              <a:defRPr sz="1425" b="0">
-                <a:solidFill>
-                  <a:srgbClr val="B1C6C9"/>
+              <a:defRPr sz="1575" b="0">
+                <a:solidFill>
+                  <a:srgbClr val="EAF2F0"/>
                 </a:solidFill>
               </a:defRPr>
             </a:defPPr>
             <a:lvl1pPr>
-              <a:defRPr sz="1425" b="0">
-                <a:solidFill>
-                  <a:srgbClr val="B1C6C9"/>
+              <a:defRPr sz="1575" b="0">
+                <a:solidFill>
+                  <a:srgbClr val="EAF2F0"/>
                 </a:solidFill>
               </a:defRPr>
             </a:lvl1pPr>
             <a:lvl2pPr>
-              <a:defRPr sz="1425" b="0">
-                <a:solidFill>
-                  <a:srgbClr val="B1C6C9"/>
+              <a:defRPr sz="1575" b="0">
+                <a:solidFill>
+                  <a:srgbClr val="EAF2F0"/>
                 </a:solidFill>
               </a:defRPr>
             </a:lvl2pPr>
             <a:lvl3pPr>
-              <a:defRPr sz="1425" b="0">
-                <a:solidFill>
-                  <a:srgbClr val="B1C6C9"/>
+              <a:defRPr sz="1575" b="0">
+                <a:solidFill>
+                  <a:srgbClr val="EAF2F0"/>
                 </a:solidFill>
               </a:defRPr>
             </a:lvl3pPr>
             <a:lvl4pPr>
-              <a:defRPr sz="1425" b="0">
-                <a:solidFill>
-                  <a:srgbClr val="B1C6C9"/>
+              <a:defRPr sz="1575" b="0">
+                <a:solidFill>
+                  <a:srgbClr val="EAF2F0"/>
                 </a:solidFill>
               </a:defRPr>
             </a:lvl4pPr>
             <a:lvl5pPr>
-              <a:defRPr sz="1425" b="0">
-                <a:solidFill>
-                  <a:srgbClr val="B1C6C9"/>
+              <a:defRPr sz="1575" b="0">
+                <a:solidFill>
+                  <a:srgbClr val="EAF2F0"/>
                 </a:solidFill>
               </a:defRPr>
             </a:lvl5pPr>
             <a:lvl6pPr>
-              <a:defRPr sz="1425" b="0">
-                <a:solidFill>
-                  <a:srgbClr val="B1C6C9"/>
+              <a:defRPr sz="1575" b="0">
+                <a:solidFill>
+                  <a:srgbClr val="EAF2F0"/>
                 </a:solidFill>
               </a:defRPr>
             </a:lvl6pPr>
             <a:lvl7pPr>
-              <a:defRPr sz="1425" b="0">
-                <a:solidFill>
-                  <a:srgbClr val="B1C6C9"/>
+              <a:defRPr sz="1575" b="0">
+                <a:solidFill>
+                  <a:srgbClr val="EAF2F0"/>
                 </a:solidFill>
               </a:defRPr>
             </a:lvl7pPr>
             <a:lvl8pPr>
-              <a:defRPr sz="1425" b="0">
-                <a:solidFill>
-                  <a:srgbClr val="B1C6C9"/>
+              <a:defRPr sz="1575" b="0">
+                <a:solidFill>
+                  <a:srgbClr val="EAF2F0"/>
                 </a:solidFill>
               </a:defRPr>
             </a:lvl8pPr>
             <a:lvl9pPr>
-              <a:defRPr sz="1425" b="0">
-                <a:solidFill>
-                  <a:srgbClr val="B1C6C9"/>
+              <a:defRPr sz="1575" b="0">
+                <a:solidFill>
+                  <a:srgbClr val="EAF2F0"/>
                 </a:solidFill>
               </a:defRPr>
             </a:lvl9pPr>
           </a:lstStyle>
           <a:p xmlns:a="http://schemas.openxmlformats.org/drawingml/2006/main">
             <a:pPr>
-              <a:defRPr sz="1425" b="0">
-                <a:solidFill>
-                  <a:srgbClr val="B1C6C9"/>
+              <a:defRPr sz="1575" b="0">
+                <a:solidFill>
+                  <a:srgbClr val="EAF2F0"/>
                 </a:solidFill>
               </a:defRPr>
             </a:pPr>
             <a:r>
-              <a:rPr sz="1425" b="0">
-                <a:solidFill>
-                  <a:srgbClr val="B1C6C9"/>
+              <a:rPr sz="1575" b="0">
+                <a:solidFill>
+                  <a:srgbClr val="EAF2F0"/>
                 </a:solidFill>
               </a:rPr>
-              <a:t>公网部署仍需 TLS、可信代理、最小权限与配套备份。</a:t>
+              <a:t>启动：workbench.cmd start   状态：status   停止：stop</a:t>
             </a:r>
           </a:p>
         </p:txBody>
       </p:sp>
+      <p:sp>
+        <p:nvSpPr>
+          <p:cNvPr id="25" name="">
+            <a:extLst xmlns:a="http://schemas.openxmlformats.org/drawingml/2006/main">
+              <a:ext uri="{FF2B5EF4-FFF2-40B4-BE49-F238E27FC236}">
+                <a16:creationId xmlns:a16="http://schemas.microsoft.com/office/drawing/2014/main" id="{7D1364F0-07DD-4D3C-B345-964DDBD8BFB2}"/>
+              </a:ext>
+            </a:extLst>
+          </p:cNvPr>
+          <p:cNvSpPr>
+            <a:spLocks xmlns:a="http://schemas.openxmlformats.org/drawingml/2006/main" noGrp="1"/>
+          </p:cNvSpPr>
+          <p:nvPr/>
+        </p:nvSpPr>
+        <p:spPr>
+          <a:xfrm xmlns:a="http://schemas.openxmlformats.org/drawingml/2006/main">
+            <a:off x="781050" y="6076950"/>
+            <a:ext cx="10572750" cy="266700"/>
+          </a:xfrm>
+          <a:prstGeom xmlns:a="http://schemas.openxmlformats.org/drawingml/2006/main" prst="rect">
+            <a:avLst/>
+          </a:prstGeom>
+          <a:noFill xmlns:a="http://schemas.openxmlformats.org/drawingml/2006/main"/>
+          <a:ln xmlns:a="http://schemas.openxmlformats.org/drawingml/2006/main" w="0">
+            <a:noFill/>
+            <a:prstDash val="solid"/>
+          </a:ln>
+        </p:spPr>
+        <p:txBody>
+          <a:bodyPr xmlns:a="http://schemas.openxmlformats.org/drawingml/2006/main" lIns="0" tIns="0" rIns="0" bIns="0"/>
+          <a:lstStyle xmlns:a="http://schemas.openxmlformats.org/drawingml/2006/main">
+            <a:defPPr>
+              <a:defRPr sz="1275" b="0">
+                <a:solidFill>
+                  <a:srgbClr val="B1C6C9"/>
+                </a:solidFill>
+              </a:defRPr>
+            </a:defPPr>
+            <a:lvl1pPr>
+              <a:defRPr sz="1275" b="0">
+                <a:solidFill>
+                  <a:srgbClr val="B1C6C9"/>
+                </a:solidFill>
+              </a:defRPr>
+            </a:lvl1pPr>
+            <a:lvl2pPr>
+              <a:defRPr sz="1275" b="0">
+                <a:solidFill>
+                  <a:srgbClr val="B1C6C9"/>
+                </a:solidFill>
+              </a:defRPr>
+            </a:lvl2pPr>
+            <a:lvl3pPr>
+              <a:defRPr sz="1275" b="0">
+                <a:solidFill>
+                  <a:srgbClr val="B1C6C9"/>
+                </a:solidFill>
+              </a:defRPr>
+            </a:lvl3pPr>
+            <a:lvl4pPr>
+              <a:defRPr sz="1275" b="0">
+                <a:solidFill>
+                  <a:srgbClr val="B1C6C9"/>
+                </a:solidFill>
+              </a:defRPr>
+            </a:lvl4pPr>
+            <a:lvl5pPr>
+              <a:defRPr sz="1275" b="0">
+                <a:solidFill>
+                  <a:srgbClr val="B1C6C9"/>
+                </a:solidFill>
+              </a:defRPr>
+            </a:lvl5pPr>
+            <a:lvl6pPr>
+              <a:defRPr sz="1275" b="0">
+                <a:solidFill>
+                  <a:srgbClr val="B1C6C9"/>
+                </a:solidFill>
+              </a:defRPr>
+            </a:lvl6pPr>
+            <a:lvl7pPr>
+              <a:defRPr sz="1275" b="0">
+                <a:solidFill>
+                  <a:srgbClr val="B1C6C9"/>
+                </a:solidFill>
+              </a:defRPr>
+            </a:lvl7pPr>
+            <a:lvl8pPr>
+              <a:defRPr sz="1275" b="0">
+                <a:solidFill>
+                  <a:srgbClr val="B1C6C9"/>
+                </a:solidFill>
+              </a:defRPr>
+            </a:lvl8pPr>
+            <a:lvl9pPr>
+              <a:defRPr sz="1275" b="0">
+                <a:solidFill>
+                  <a:srgbClr val="B1C6C9"/>
+                </a:solidFill>
+              </a:defRPr>
+            </a:lvl9pPr>
+          </a:lstStyle>
+          <a:p xmlns:a="http://schemas.openxmlformats.org/drawingml/2006/main">
+            <a:pPr>
+              <a:defRPr sz="1275" b="0">
+                <a:solidFill>
+                  <a:srgbClr val="B1C6C9"/>
+                </a:solidFill>
+              </a:defRPr>
+            </a:pPr>
+            <a:r>
+              <a:rPr sz="1275" b="0">
+                <a:solidFill>
+                  <a:srgbClr val="B1C6C9"/>
+                </a:solidFill>
+              </a:rPr>
+              <a:t>公网部署需 TLS、可信代理、最小权限与配套备份。</a:t>
+            </a:r>
+          </a:p>
+        </p:txBody>
+      </p:sp>
     </p:spTree>
     <p:extLst>
       <p:ext uri="{BB962C8B-B14F-4D97-AF65-F5344CB8AC3E}">
-        <p14:creationId xmlns:p14="http://schemas.microsoft.com/office/powerpoint/2010/main" val="1366075674"/>
+        <p14:creationId xmlns:p14="http://schemas.microsoft.com/office/powerpoint/2010/main" val="1652100524"/>
       </p:ext>
     </p:extLst>
   </p:cSld>
@@ -9706,7 +9827,7 @@
           <p:cNvPr id="17" name="">
             <a:extLst xmlns:a="http://schemas.openxmlformats.org/drawingml/2006/main">
               <a:ext uri="{FF2B5EF4-FFF2-40B4-BE49-F238E27FC236}">
-                <a16:creationId xmlns:a16="http://schemas.microsoft.com/office/drawing/2014/main" id="{0809A41B-FA1A-42B5-82EF-895700F592ED}"/>
+                <a16:creationId xmlns:a16="http://schemas.microsoft.com/office/drawing/2014/main" id="{4074E158-DDB0-482F-9E7A-D410033C4F23}"/>
               </a:ext>
             </a:extLst>
           </p:cNvPr>
@@ -9737,7 +9858,7 @@
           <p:cNvPr id="2" name="">
             <a:extLst xmlns:a="http://schemas.openxmlformats.org/drawingml/2006/main">
               <a:ext uri="{FF2B5EF4-FFF2-40B4-BE49-F238E27FC236}">
-                <a16:creationId xmlns:a16="http://schemas.microsoft.com/office/drawing/2014/main" id="{3CA8F8AE-AEAA-49B7-BFB2-D0F47CF5C2FB}"/>
+                <a16:creationId xmlns:a16="http://schemas.microsoft.com/office/drawing/2014/main" id="{12A17E68-D31B-40AF-8AFD-6F4955EF8BF3}"/>
               </a:ext>
             </a:extLst>
           </p:cNvPr>
@@ -9858,7 +9979,7 @@
           <p:cNvPr id="3" name="">
             <a:extLst xmlns:a="http://schemas.openxmlformats.org/drawingml/2006/main">
               <a:ext uri="{FF2B5EF4-FFF2-40B4-BE49-F238E27FC236}">
-                <a16:creationId xmlns:a16="http://schemas.microsoft.com/office/drawing/2014/main" id="{7FA27C61-5268-4F83-A72C-80C6672D24D9}"/>
+                <a16:creationId xmlns:a16="http://schemas.microsoft.com/office/drawing/2014/main" id="{A3A2CDA2-2363-48FF-A4E5-33B631234DA2}"/>
               </a:ext>
             </a:extLst>
           </p:cNvPr>
@@ -9979,7 +10100,7 @@
           <p:cNvPr id="4" name="">
             <a:extLst xmlns:a="http://schemas.openxmlformats.org/drawingml/2006/main">
               <a:ext uri="{FF2B5EF4-FFF2-40B4-BE49-F238E27FC236}">
-                <a16:creationId xmlns:a16="http://schemas.microsoft.com/office/drawing/2014/main" id="{C66985DB-DD61-4566-9F4E-D7C338776EA0}"/>
+                <a16:creationId xmlns:a16="http://schemas.microsoft.com/office/drawing/2014/main" id="{583FDF69-4252-479C-880C-BA944ABA5667}"/>
               </a:ext>
             </a:extLst>
           </p:cNvPr>
@@ -10100,7 +10221,7 @@
           <p:cNvPr id="5" name="">
             <a:extLst xmlns:a="http://schemas.openxmlformats.org/drawingml/2006/main">
               <a:ext uri="{FF2B5EF4-FFF2-40B4-BE49-F238E27FC236}">
-                <a16:creationId xmlns:a16="http://schemas.microsoft.com/office/drawing/2014/main" id="{78660055-8739-47E4-8A77-98268808C6ED}"/>
+                <a16:creationId xmlns:a16="http://schemas.microsoft.com/office/drawing/2014/main" id="{E4C2B15E-B6F0-46AF-8C8C-51FF67706483}"/>
               </a:ext>
             </a:extLst>
           </p:cNvPr>
@@ -10131,7 +10252,7 @@
           <p:cNvPr id="6" name="">
             <a:extLst xmlns:a="http://schemas.openxmlformats.org/drawingml/2006/main">
               <a:ext uri="{FF2B5EF4-FFF2-40B4-BE49-F238E27FC236}">
-                <a16:creationId xmlns:a16="http://schemas.microsoft.com/office/drawing/2014/main" id="{3CB0A007-5121-438D-94FB-B430E43984A9}"/>
+                <a16:creationId xmlns:a16="http://schemas.microsoft.com/office/drawing/2014/main" id="{785F9872-462F-4E5C-9BA9-D3E3B9BE92D3}"/>
               </a:ext>
             </a:extLst>
           </p:cNvPr>
@@ -10252,7 +10373,7 @@
           <p:cNvPr id="7" name="">
             <a:extLst xmlns:a="http://schemas.openxmlformats.org/drawingml/2006/main">
               <a:ext uri="{FF2B5EF4-FFF2-40B4-BE49-F238E27FC236}">
-                <a16:creationId xmlns:a16="http://schemas.microsoft.com/office/drawing/2014/main" id="{9A761011-1380-416C-B892-7839E55D4416}"/>
+                <a16:creationId xmlns:a16="http://schemas.microsoft.com/office/drawing/2014/main" id="{4A9C36BD-55EB-45BB-805E-E61D69C87FCE}"/>
               </a:ext>
             </a:extLst>
           </p:cNvPr>
@@ -10262,7 +10383,7 @@
           <p:nvPr/>
         </p:nvPicPr>
         <p:blipFill>
-          <a:blip xmlns:r="http://schemas.openxmlformats.org/officeDocument/2006/relationships" xmlns:a="http://schemas.openxmlformats.org/drawingml/2006/main" r:embed="R5591ed900ae847f3"/>
+          <a:blip xmlns:r="http://schemas.openxmlformats.org/officeDocument/2006/relationships" xmlns:a="http://schemas.openxmlformats.org/drawingml/2006/main" r:embed="R58be150c173344df"/>
           <a:stretch xmlns:a="http://schemas.openxmlformats.org/drawingml/2006/main"/>
         </p:blipFill>
         <p:spPr>
@@ -10280,7 +10401,7 @@
           <p:cNvPr id="8" name="">
             <a:extLst xmlns:a="http://schemas.openxmlformats.org/drawingml/2006/main">
               <a:ext uri="{FF2B5EF4-FFF2-40B4-BE49-F238E27FC236}">
-                <a16:creationId xmlns:a16="http://schemas.microsoft.com/office/drawing/2014/main" id="{E48E1E52-2D62-43DA-BDDA-AD8797C40CB1}"/>
+                <a16:creationId xmlns:a16="http://schemas.microsoft.com/office/drawing/2014/main" id="{0B30BAEA-3A23-4F7A-93B2-286A3D7EAFC6}"/>
               </a:ext>
             </a:extLst>
           </p:cNvPr>
@@ -10311,7 +10432,7 @@
           <p:cNvPr id="9" name="">
             <a:extLst xmlns:a="http://schemas.openxmlformats.org/drawingml/2006/main">
               <a:ext uri="{FF2B5EF4-FFF2-40B4-BE49-F238E27FC236}">
-                <a16:creationId xmlns:a16="http://schemas.microsoft.com/office/drawing/2014/main" id="{11B8D4F7-CC8B-46E1-B039-F6BC24808190}"/>
+                <a16:creationId xmlns:a16="http://schemas.microsoft.com/office/drawing/2014/main" id="{87DE316D-1B94-4BE0-8D5E-F4A39C6FBD28}"/>
               </a:ext>
             </a:extLst>
           </p:cNvPr>
@@ -10422,7 +10543,7 @@
                   <a:srgbClr val="102A38"/>
                 </a:solidFill>
               </a:rPr>
-              <a:t>W00 → W01</a:t>
+              <a:t>选择与预览</a:t>
             </a:r>
           </a:p>
         </p:txBody>
@@ -10432,7 +10553,7 @@
           <p:cNvPr id="10" name="">
             <a:extLst xmlns:a="http://schemas.openxmlformats.org/drawingml/2006/main">
               <a:ext uri="{FF2B5EF4-FFF2-40B4-BE49-F238E27FC236}">
-                <a16:creationId xmlns:a16="http://schemas.microsoft.com/office/drawing/2014/main" id="{545AE733-8165-4CF3-847B-09712591A788}"/>
+                <a16:creationId xmlns:a16="http://schemas.microsoft.com/office/drawing/2014/main" id="{590E671A-3BEF-45FB-A57B-10D1D24937EE}"/>
               </a:ext>
             </a:extLst>
           </p:cNvPr>
@@ -10553,7 +10674,7 @@
           <p:cNvPr id="11" name="">
             <a:extLst xmlns:a="http://schemas.openxmlformats.org/drawingml/2006/main">
               <a:ext uri="{FF2B5EF4-FFF2-40B4-BE49-F238E27FC236}">
-                <a16:creationId xmlns:a16="http://schemas.microsoft.com/office/drawing/2014/main" id="{347A6152-0F20-498F-9833-6937C8256164}"/>
+                <a16:creationId xmlns:a16="http://schemas.microsoft.com/office/drawing/2014/main" id="{D5BD3DFC-DF2E-4D78-9CEF-3C430B8CB3E7}"/>
               </a:ext>
             </a:extLst>
           </p:cNvPr>
@@ -10584,7 +10705,7 @@
           <p:cNvPr id="12" name="">
             <a:extLst xmlns:a="http://schemas.openxmlformats.org/drawingml/2006/main">
               <a:ext uri="{FF2B5EF4-FFF2-40B4-BE49-F238E27FC236}">
-                <a16:creationId xmlns:a16="http://schemas.microsoft.com/office/drawing/2014/main" id="{6A61DB9D-0764-43DF-BD79-5FF1E79DF3E6}"/>
+                <a16:creationId xmlns:a16="http://schemas.microsoft.com/office/drawing/2014/main" id="{9B8E5FCE-655C-4A7E-B18B-27D183B4EFC3}"/>
               </a:ext>
             </a:extLst>
           </p:cNvPr>
@@ -10695,7 +10816,7 @@
                   <a:srgbClr val="102A38"/>
                 </a:solidFill>
               </a:rPr>
-              <a:t>W02 → W08</a:t>
+              <a:t>切换工具</a:t>
             </a:r>
           </a:p>
         </p:txBody>
@@ -10705,7 +10826,7 @@
           <p:cNvPr id="13" name="">
             <a:extLst xmlns:a="http://schemas.openxmlformats.org/drawingml/2006/main">
               <a:ext uri="{FF2B5EF4-FFF2-40B4-BE49-F238E27FC236}">
-                <a16:creationId xmlns:a16="http://schemas.microsoft.com/office/drawing/2014/main" id="{FA7CF4A0-996C-4B9F-9AF2-680545445BA5}"/>
+                <a16:creationId xmlns:a16="http://schemas.microsoft.com/office/drawing/2014/main" id="{7A565DA3-A019-4638-BABD-4E079FEEC7C2}"/>
               </a:ext>
             </a:extLst>
           </p:cNvPr>
@@ -10826,7 +10947,7 @@
           <p:cNvPr id="14" name="">
             <a:extLst xmlns:a="http://schemas.openxmlformats.org/drawingml/2006/main">
               <a:ext uri="{FF2B5EF4-FFF2-40B4-BE49-F238E27FC236}">
-                <a16:creationId xmlns:a16="http://schemas.microsoft.com/office/drawing/2014/main" id="{B53ED791-7373-44CC-97E3-15524629CA4D}"/>
+                <a16:creationId xmlns:a16="http://schemas.microsoft.com/office/drawing/2014/main" id="{99D9CF61-BE87-49EC-A53C-2660EB65EAD9}"/>
               </a:ext>
             </a:extLst>
           </p:cNvPr>
@@ -10857,7 +10978,7 @@
           <p:cNvPr id="15" name="">
             <a:extLst xmlns:a="http://schemas.openxmlformats.org/drawingml/2006/main">
               <a:ext uri="{FF2B5EF4-FFF2-40B4-BE49-F238E27FC236}">
-                <a16:creationId xmlns:a16="http://schemas.microsoft.com/office/drawing/2014/main" id="{7002B643-B771-42EA-981F-88273CC40449}"/>
+                <a16:creationId xmlns:a16="http://schemas.microsoft.com/office/drawing/2014/main" id="{BF2FC1AB-79F2-4A11-B1AD-40C9024A5F08}"/>
               </a:ext>
             </a:extLst>
           </p:cNvPr>
@@ -10968,7 +11089,7 @@
                   <a:srgbClr val="102A38"/>
                 </a:solidFill>
               </a:rPr>
-              <a:t>W09 → W10</a:t>
+              <a:t>结果与错误</a:t>
             </a:r>
           </a:p>
         </p:txBody>
@@ -10978,7 +11099,7 @@
           <p:cNvPr id="16" name="">
             <a:extLst xmlns:a="http://schemas.openxmlformats.org/drawingml/2006/main">
               <a:ext uri="{FF2B5EF4-FFF2-40B4-BE49-F238E27FC236}">
-                <a16:creationId xmlns:a16="http://schemas.microsoft.com/office/drawing/2014/main" id="{29DBF6C4-B166-4273-8D2E-3DAB174799E4}"/>
+                <a16:creationId xmlns:a16="http://schemas.microsoft.com/office/drawing/2014/main" id="{09F70C75-B853-495D-9D50-8E7E49D5F409}"/>
               </a:ext>
             </a:extLst>
           </p:cNvPr>
@@ -11097,7 +11218,7 @@
     </p:spTree>
     <p:extLst>
       <p:ext uri="{BB962C8B-B14F-4D97-AF65-F5344CB8AC3E}">
-        <p14:creationId xmlns:p14="http://schemas.microsoft.com/office/powerpoint/2010/main" val="316591817"/>
+        <p14:creationId xmlns:p14="http://schemas.microsoft.com/office/powerpoint/2010/main" val="707613468"/>
       </p:ext>
     </p:extLst>
   </p:cSld>
@@ -11128,7 +11249,7 @@
           <p:cNvPr id="17" name="">
             <a:extLst xmlns:a="http://schemas.openxmlformats.org/drawingml/2006/main">
               <a:ext uri="{FF2B5EF4-FFF2-40B4-BE49-F238E27FC236}">
-                <a16:creationId xmlns:a16="http://schemas.microsoft.com/office/drawing/2014/main" id="{1387C892-6DC6-4FDA-B1D7-EB30AA0B5945}"/>
+                <a16:creationId xmlns:a16="http://schemas.microsoft.com/office/drawing/2014/main" id="{B2E4F893-1FDE-4130-964D-7C95C9AB1A0A}"/>
               </a:ext>
             </a:extLst>
           </p:cNvPr>
@@ -11159,7 +11280,7 @@
           <p:cNvPr id="2" name="">
             <a:extLst xmlns:a="http://schemas.openxmlformats.org/drawingml/2006/main">
               <a:ext uri="{FF2B5EF4-FFF2-40B4-BE49-F238E27FC236}">
-                <a16:creationId xmlns:a16="http://schemas.microsoft.com/office/drawing/2014/main" id="{0556C20B-D302-4E8C-9ACA-2916BCD91E86}"/>
+                <a16:creationId xmlns:a16="http://schemas.microsoft.com/office/drawing/2014/main" id="{042E2B12-EF0E-47AA-99E5-BA540069A575}"/>
               </a:ext>
             </a:extLst>
           </p:cNvPr>
@@ -11280,7 +11401,7 @@
           <p:cNvPr id="3" name="">
             <a:extLst xmlns:a="http://schemas.openxmlformats.org/drawingml/2006/main">
               <a:ext uri="{FF2B5EF4-FFF2-40B4-BE49-F238E27FC236}">
-                <a16:creationId xmlns:a16="http://schemas.microsoft.com/office/drawing/2014/main" id="{4A119165-3942-4943-9D20-C2FB71CAF598}"/>
+                <a16:creationId xmlns:a16="http://schemas.microsoft.com/office/drawing/2014/main" id="{5311C76C-DB46-4CA6-B928-EF15B677E7AD}"/>
               </a:ext>
             </a:extLst>
           </p:cNvPr>
@@ -11401,7 +11522,7 @@
           <p:cNvPr id="4" name="">
             <a:extLst xmlns:a="http://schemas.openxmlformats.org/drawingml/2006/main">
               <a:ext uri="{FF2B5EF4-FFF2-40B4-BE49-F238E27FC236}">
-                <a16:creationId xmlns:a16="http://schemas.microsoft.com/office/drawing/2014/main" id="{A0032FAE-0694-42B1-8437-3EDF28C1D133}"/>
+                <a16:creationId xmlns:a16="http://schemas.microsoft.com/office/drawing/2014/main" id="{13DAD819-656E-4999-8943-5A922B3D95A0}"/>
               </a:ext>
             </a:extLst>
           </p:cNvPr>
@@ -11522,7 +11643,7 @@
           <p:cNvPr id="5" name="">
             <a:extLst xmlns:a="http://schemas.openxmlformats.org/drawingml/2006/main">
               <a:ext uri="{FF2B5EF4-FFF2-40B4-BE49-F238E27FC236}">
-                <a16:creationId xmlns:a16="http://schemas.microsoft.com/office/drawing/2014/main" id="{374F5F37-B00F-4A3B-AC69-A742F5365002}"/>
+                <a16:creationId xmlns:a16="http://schemas.microsoft.com/office/drawing/2014/main" id="{BD69FCD0-81DE-4FC9-82DA-5A1F874AF4B3}"/>
               </a:ext>
             </a:extLst>
           </p:cNvPr>
@@ -11553,7 +11674,7 @@
           <p:cNvPr id="6" name="">
             <a:extLst xmlns:a="http://schemas.openxmlformats.org/drawingml/2006/main">
               <a:ext uri="{FF2B5EF4-FFF2-40B4-BE49-F238E27FC236}">
-                <a16:creationId xmlns:a16="http://schemas.microsoft.com/office/drawing/2014/main" id="{407B5412-9C7D-45CF-A521-38B4F5022BA8}"/>
+                <a16:creationId xmlns:a16="http://schemas.microsoft.com/office/drawing/2014/main" id="{EF36F7D5-0993-424A-BFD3-75D40DC12A0C}"/>
               </a:ext>
             </a:extLst>
           </p:cNvPr>
@@ -11674,7 +11795,7 @@
           <p:cNvPr id="7" name="">
             <a:extLst xmlns:a="http://schemas.openxmlformats.org/drawingml/2006/main">
               <a:ext uri="{FF2B5EF4-FFF2-40B4-BE49-F238E27FC236}">
-                <a16:creationId xmlns:a16="http://schemas.microsoft.com/office/drawing/2014/main" id="{45984326-FE31-403F-A2FC-9B38E072FAA9}"/>
+                <a16:creationId xmlns:a16="http://schemas.microsoft.com/office/drawing/2014/main" id="{315D6D4F-A492-4885-8EC3-B72CA76A7D04}"/>
               </a:ext>
             </a:extLst>
           </p:cNvPr>
@@ -11684,13 +11805,13 @@
           <p:nvPr/>
         </p:nvPicPr>
         <p:blipFill>
-          <a:blip xmlns:r="http://schemas.openxmlformats.org/officeDocument/2006/relationships" xmlns:a="http://schemas.openxmlformats.org/drawingml/2006/main" r:embed="R5948523891b04d28"/>
+          <a:blip xmlns:r="http://schemas.openxmlformats.org/officeDocument/2006/relationships" xmlns:a="http://schemas.openxmlformats.org/drawingml/2006/main" r:embed="R69ef8cee4185469c"/>
           <a:stretch xmlns:a="http://schemas.openxmlformats.org/drawingml/2006/main"/>
         </p:blipFill>
         <p:spPr>
           <a:xfrm xmlns:a="http://schemas.openxmlformats.org/drawingml/2006/main">
-            <a:off x="1660647" y="2162175"/>
-            <a:ext cx="5308356" cy="3943350"/>
+            <a:off x="2106549" y="2162175"/>
+            <a:ext cx="4416552" cy="3943350"/>
           </a:xfrm>
           <a:prstGeom xmlns:a="http://schemas.openxmlformats.org/drawingml/2006/main" prst="rect">
             <a:avLst/>
@@ -11702,7 +11823,7 @@
           <p:cNvPr id="8" name="">
             <a:extLst xmlns:a="http://schemas.openxmlformats.org/drawingml/2006/main">
               <a:ext uri="{FF2B5EF4-FFF2-40B4-BE49-F238E27FC236}">
-                <a16:creationId xmlns:a16="http://schemas.microsoft.com/office/drawing/2014/main" id="{39A10FE2-E1DF-494E-BCDD-009E7E6B813C}"/>
+                <a16:creationId xmlns:a16="http://schemas.microsoft.com/office/drawing/2014/main" id="{55F25A8B-4A8A-470C-9623-9908E8647375}"/>
               </a:ext>
             </a:extLst>
           </p:cNvPr>
@@ -11733,7 +11854,7 @@
           <p:cNvPr id="9" name="">
             <a:extLst xmlns:a="http://schemas.openxmlformats.org/drawingml/2006/main">
               <a:ext uri="{FF2B5EF4-FFF2-40B4-BE49-F238E27FC236}">
-                <a16:creationId xmlns:a16="http://schemas.microsoft.com/office/drawing/2014/main" id="{5EEAD41C-9DA9-4A8E-A761-09C4D643CC19}"/>
+                <a16:creationId xmlns:a16="http://schemas.microsoft.com/office/drawing/2014/main" id="{F0E36F65-6712-47AD-853C-C756EF904F4C}"/>
               </a:ext>
             </a:extLst>
           </p:cNvPr>
@@ -11854,7 +11975,7 @@
           <p:cNvPr id="10" name="">
             <a:extLst xmlns:a="http://schemas.openxmlformats.org/drawingml/2006/main">
               <a:ext uri="{FF2B5EF4-FFF2-40B4-BE49-F238E27FC236}">
-                <a16:creationId xmlns:a16="http://schemas.microsoft.com/office/drawing/2014/main" id="{923F4A17-026B-408B-BA9E-1728EC8EFEB7}"/>
+                <a16:creationId xmlns:a16="http://schemas.microsoft.com/office/drawing/2014/main" id="{01957A6D-61A7-41CF-A3CD-ACEAF6BEAC79}"/>
               </a:ext>
             </a:extLst>
           </p:cNvPr>
@@ -11975,7 +12096,7 @@
           <p:cNvPr id="11" name="">
             <a:extLst xmlns:a="http://schemas.openxmlformats.org/drawingml/2006/main">
               <a:ext uri="{FF2B5EF4-FFF2-40B4-BE49-F238E27FC236}">
-                <a16:creationId xmlns:a16="http://schemas.microsoft.com/office/drawing/2014/main" id="{AA7B55E3-7206-4D7A-A4AE-301FB81A2392}"/>
+                <a16:creationId xmlns:a16="http://schemas.microsoft.com/office/drawing/2014/main" id="{11BFF67A-EF19-47EE-8CE6-BB0076BAB7AF}"/>
               </a:ext>
             </a:extLst>
           </p:cNvPr>
@@ -12006,7 +12127,7 @@
           <p:cNvPr id="12" name="">
             <a:extLst xmlns:a="http://schemas.openxmlformats.org/drawingml/2006/main">
               <a:ext uri="{FF2B5EF4-FFF2-40B4-BE49-F238E27FC236}">
-                <a16:creationId xmlns:a16="http://schemas.microsoft.com/office/drawing/2014/main" id="{CF34259C-F811-42B1-8A3F-53308225ADDF}"/>
+                <a16:creationId xmlns:a16="http://schemas.microsoft.com/office/drawing/2014/main" id="{7073DB5A-C2C3-4F59-8069-5AD8287BAD8D}"/>
               </a:ext>
             </a:extLst>
           </p:cNvPr>
@@ -12127,7 +12248,7 @@
           <p:cNvPr id="13" name="">
             <a:extLst xmlns:a="http://schemas.openxmlformats.org/drawingml/2006/main">
               <a:ext uri="{FF2B5EF4-FFF2-40B4-BE49-F238E27FC236}">
-                <a16:creationId xmlns:a16="http://schemas.microsoft.com/office/drawing/2014/main" id="{112072CE-434A-48D8-8C35-34BE2B1488E2}"/>
+                <a16:creationId xmlns:a16="http://schemas.microsoft.com/office/drawing/2014/main" id="{AFF07369-B695-4E72-AD2D-D0FE9FE6E809}"/>
               </a:ext>
             </a:extLst>
           </p:cNvPr>
@@ -12238,7 +12359,7 @@
                   <a:srgbClr val="5C6C70"/>
                 </a:solidFill>
               </a:rPr>
-              <a:t>核心 PDF 运算仍在 Web JVM 内。</a:t>
+              <a:t>适配请求并管理独立 PDF 子进程。</a:t>
             </a:r>
           </a:p>
         </p:txBody>
@@ -12248,7 +12369,7 @@
           <p:cNvPr id="14" name="">
             <a:extLst xmlns:a="http://schemas.openxmlformats.org/drawingml/2006/main">
               <a:ext uri="{FF2B5EF4-FFF2-40B4-BE49-F238E27FC236}">
-                <a16:creationId xmlns:a16="http://schemas.microsoft.com/office/drawing/2014/main" id="{BDD4C230-0A7A-4201-A886-136D170F4246}"/>
+                <a16:creationId xmlns:a16="http://schemas.microsoft.com/office/drawing/2014/main" id="{1DC04227-1866-479B-B5B3-5FBB02753586}"/>
               </a:ext>
             </a:extLst>
           </p:cNvPr>
@@ -12279,7 +12400,7 @@
           <p:cNvPr id="15" name="">
             <a:extLst xmlns:a="http://schemas.openxmlformats.org/drawingml/2006/main">
               <a:ext uri="{FF2B5EF4-FFF2-40B4-BE49-F238E27FC236}">
-                <a16:creationId xmlns:a16="http://schemas.microsoft.com/office/drawing/2014/main" id="{D4D5DD11-5666-4EBF-A7AF-E976FD8170C5}"/>
+                <a16:creationId xmlns:a16="http://schemas.microsoft.com/office/drawing/2014/main" id="{B9066E4D-9979-4439-95B1-A43A129FCB25}"/>
               </a:ext>
             </a:extLst>
           </p:cNvPr>
@@ -12390,7 +12511,7 @@
                   <a:srgbClr val="102A38"/>
                 </a:solidFill>
               </a:rPr>
-              <a:t>后台服务</a:t>
+              <a:t>PDF 子进程</a:t>
             </a:r>
           </a:p>
         </p:txBody>
@@ -12400,7 +12521,7 @@
           <p:cNvPr id="16" name="">
             <a:extLst xmlns:a="http://schemas.openxmlformats.org/drawingml/2006/main">
               <a:ext uri="{FF2B5EF4-FFF2-40B4-BE49-F238E27FC236}">
-                <a16:creationId xmlns:a16="http://schemas.microsoft.com/office/drawing/2014/main" id="{EB428F4D-A049-4FF6-BA70-B2E4B7B1FB5A}"/>
+                <a16:creationId xmlns:a16="http://schemas.microsoft.com/office/drawing/2014/main" id="{D341FD9A-C35C-450A-982E-71909570AE76}"/>
               </a:ext>
             </a:extLst>
           </p:cNvPr>
@@ -12511,7 +12632,7 @@
                   <a:srgbClr val="5C6C70"/>
                 </a:solidFill>
               </a:rPr>
-              <a:t>Worker 与持久任务独立运行。</a:t>
+              <a:t>90 秒期限，退出后回收临时文件。</a:t>
             </a:r>
           </a:p>
         </p:txBody>
@@ -12519,7 +12640,7 @@
     </p:spTree>
     <p:extLst>
       <p:ext uri="{BB962C8B-B14F-4D97-AF65-F5344CB8AC3E}">
-        <p14:creationId xmlns:p14="http://schemas.microsoft.com/office/powerpoint/2010/main" val="622090174"/>
+        <p14:creationId xmlns:p14="http://schemas.microsoft.com/office/powerpoint/2010/main" val="689791303"/>
       </p:ext>
     </p:extLst>
   </p:cSld>
@@ -12550,7 +12671,7 @@
           <p:cNvPr id="17" name="">
             <a:extLst xmlns:a="http://schemas.openxmlformats.org/drawingml/2006/main">
               <a:ext uri="{FF2B5EF4-FFF2-40B4-BE49-F238E27FC236}">
-                <a16:creationId xmlns:a16="http://schemas.microsoft.com/office/drawing/2014/main" id="{231E5F1C-D879-46FA-BE6A-3CA459069ED4}"/>
+                <a16:creationId xmlns:a16="http://schemas.microsoft.com/office/drawing/2014/main" id="{EE13518A-7563-4F4C-B1A6-306496F93F43}"/>
               </a:ext>
             </a:extLst>
           </p:cNvPr>
@@ -12581,7 +12702,7 @@
           <p:cNvPr id="2" name="">
             <a:extLst xmlns:a="http://schemas.openxmlformats.org/drawingml/2006/main">
               <a:ext uri="{FF2B5EF4-FFF2-40B4-BE49-F238E27FC236}">
-                <a16:creationId xmlns:a16="http://schemas.microsoft.com/office/drawing/2014/main" id="{D62A1777-C267-4D36-83A2-FD49E5416958}"/>
+                <a16:creationId xmlns:a16="http://schemas.microsoft.com/office/drawing/2014/main" id="{5C8B5F90-9A3F-4C53-8063-62370B36C3C2}"/>
               </a:ext>
             </a:extLst>
           </p:cNvPr>
@@ -12702,7 +12823,7 @@
           <p:cNvPr id="3" name="">
             <a:extLst xmlns:a="http://schemas.openxmlformats.org/drawingml/2006/main">
               <a:ext uri="{FF2B5EF4-FFF2-40B4-BE49-F238E27FC236}">
-                <a16:creationId xmlns:a16="http://schemas.microsoft.com/office/drawing/2014/main" id="{2333FCA8-59E8-4FDC-9AE7-6F44F109A9BD}"/>
+                <a16:creationId xmlns:a16="http://schemas.microsoft.com/office/drawing/2014/main" id="{2647915F-5CB9-475C-A1DA-2DD1BB9DE05A}"/>
               </a:ext>
             </a:extLst>
           </p:cNvPr>
@@ -12823,7 +12944,7 @@
           <p:cNvPr id="4" name="">
             <a:extLst xmlns:a="http://schemas.openxmlformats.org/drawingml/2006/main">
               <a:ext uri="{FF2B5EF4-FFF2-40B4-BE49-F238E27FC236}">
-                <a16:creationId xmlns:a16="http://schemas.microsoft.com/office/drawing/2014/main" id="{8BAD2E91-360B-43BA-8494-E8A3E886A334}"/>
+                <a16:creationId xmlns:a16="http://schemas.microsoft.com/office/drawing/2014/main" id="{5F7E40F3-58F4-4DBC-AEBC-16BCC2CE68E1}"/>
               </a:ext>
             </a:extLst>
           </p:cNvPr>
@@ -12944,7 +13065,7 @@
           <p:cNvPr id="5" name="">
             <a:extLst xmlns:a="http://schemas.openxmlformats.org/drawingml/2006/main">
               <a:ext uri="{FF2B5EF4-FFF2-40B4-BE49-F238E27FC236}">
-                <a16:creationId xmlns:a16="http://schemas.microsoft.com/office/drawing/2014/main" id="{D34B94B7-660E-433A-8469-9D71D14671FF}"/>
+                <a16:creationId xmlns:a16="http://schemas.microsoft.com/office/drawing/2014/main" id="{7FBDAE52-DDE3-441C-94F0-FADAD01297A9}"/>
               </a:ext>
             </a:extLst>
           </p:cNvPr>
@@ -12975,7 +13096,7 @@
           <p:cNvPr id="6" name="">
             <a:extLst xmlns:a="http://schemas.openxmlformats.org/drawingml/2006/main">
               <a:ext uri="{FF2B5EF4-FFF2-40B4-BE49-F238E27FC236}">
-                <a16:creationId xmlns:a16="http://schemas.microsoft.com/office/drawing/2014/main" id="{4FD36994-E6CE-4E40-8857-0E497DED9272}"/>
+                <a16:creationId xmlns:a16="http://schemas.microsoft.com/office/drawing/2014/main" id="{A8F6A758-CF2E-428C-88A8-24D8A7E90B72}"/>
               </a:ext>
             </a:extLst>
           </p:cNvPr>
@@ -13096,7 +13217,7 @@
           <p:cNvPr id="7" name="">
             <a:extLst xmlns:a="http://schemas.openxmlformats.org/drawingml/2006/main">
               <a:ext uri="{FF2B5EF4-FFF2-40B4-BE49-F238E27FC236}">
-                <a16:creationId xmlns:a16="http://schemas.microsoft.com/office/drawing/2014/main" id="{7C2708B5-9BBC-41C9-AFC9-80F1EE8BAE4C}"/>
+                <a16:creationId xmlns:a16="http://schemas.microsoft.com/office/drawing/2014/main" id="{741D82FE-FC11-415D-BBB2-637B3E980DD2}"/>
               </a:ext>
             </a:extLst>
           </p:cNvPr>
@@ -13106,7 +13227,7 @@
           <p:nvPr/>
         </p:nvPicPr>
         <p:blipFill>
-          <a:blip xmlns:r="http://schemas.openxmlformats.org/officeDocument/2006/relationships" xmlns:a="http://schemas.openxmlformats.org/drawingml/2006/main" r:embed="R2b46e2ffa8294590"/>
+          <a:blip xmlns:r="http://schemas.openxmlformats.org/officeDocument/2006/relationships" xmlns:a="http://schemas.openxmlformats.org/drawingml/2006/main" r:embed="R4f49a93f31fa464d"/>
           <a:stretch xmlns:a="http://schemas.openxmlformats.org/drawingml/2006/main"/>
         </p:blipFill>
         <p:spPr>
@@ -13124,7 +13245,7 @@
           <p:cNvPr id="8" name="">
             <a:extLst xmlns:a="http://schemas.openxmlformats.org/drawingml/2006/main">
               <a:ext uri="{FF2B5EF4-FFF2-40B4-BE49-F238E27FC236}">
-                <a16:creationId xmlns:a16="http://schemas.microsoft.com/office/drawing/2014/main" id="{704BA511-B801-40F6-89D9-6C3FCC86A209}"/>
+                <a16:creationId xmlns:a16="http://schemas.microsoft.com/office/drawing/2014/main" id="{E50AC702-0A13-430A-88FE-ECC65C97CA30}"/>
               </a:ext>
             </a:extLst>
           </p:cNvPr>
@@ -13155,7 +13276,7 @@
           <p:cNvPr id="9" name="">
             <a:extLst xmlns:a="http://schemas.openxmlformats.org/drawingml/2006/main">
               <a:ext uri="{FF2B5EF4-FFF2-40B4-BE49-F238E27FC236}">
-                <a16:creationId xmlns:a16="http://schemas.microsoft.com/office/drawing/2014/main" id="{0182C8FF-17B0-45EE-A438-0C7302219B2B}"/>
+                <a16:creationId xmlns:a16="http://schemas.microsoft.com/office/drawing/2014/main" id="{DE5AD9C4-70E1-4014-AFD5-BBF545B4E68C}"/>
               </a:ext>
             </a:extLst>
           </p:cNvPr>
@@ -13276,7 +13397,7 @@
           <p:cNvPr id="10" name="">
             <a:extLst xmlns:a="http://schemas.openxmlformats.org/drawingml/2006/main">
               <a:ext uri="{FF2B5EF4-FFF2-40B4-BE49-F238E27FC236}">
-                <a16:creationId xmlns:a16="http://schemas.microsoft.com/office/drawing/2014/main" id="{46C253B4-C43C-461A-A9E8-11F6F630C141}"/>
+                <a16:creationId xmlns:a16="http://schemas.microsoft.com/office/drawing/2014/main" id="{BB848ECF-8816-4CE8-B4DB-A6F389A4C6DA}"/>
               </a:ext>
             </a:extLst>
           </p:cNvPr>
@@ -13397,7 +13518,7 @@
           <p:cNvPr id="11" name="">
             <a:extLst xmlns:a="http://schemas.openxmlformats.org/drawingml/2006/main">
               <a:ext uri="{FF2B5EF4-FFF2-40B4-BE49-F238E27FC236}">
-                <a16:creationId xmlns:a16="http://schemas.microsoft.com/office/drawing/2014/main" id="{99972134-F7FF-4EE2-B8F4-D850F5B1233D}"/>
+                <a16:creationId xmlns:a16="http://schemas.microsoft.com/office/drawing/2014/main" id="{E7123DB6-0E85-42B9-B48E-879EBBE0ADCB}"/>
               </a:ext>
             </a:extLst>
           </p:cNvPr>
@@ -13428,7 +13549,7 @@
           <p:cNvPr id="12" name="">
             <a:extLst xmlns:a="http://schemas.openxmlformats.org/drawingml/2006/main">
               <a:ext uri="{FF2B5EF4-FFF2-40B4-BE49-F238E27FC236}">
-                <a16:creationId xmlns:a16="http://schemas.microsoft.com/office/drawing/2014/main" id="{4500ADC8-C422-48F8-A98E-F0A6215BABFD}"/>
+                <a16:creationId xmlns:a16="http://schemas.microsoft.com/office/drawing/2014/main" id="{3C1646DA-360C-4726-80A5-4BC2CED22827}"/>
               </a:ext>
             </a:extLst>
           </p:cNvPr>
@@ -13549,7 +13670,7 @@
           <p:cNvPr id="13" name="">
             <a:extLst xmlns:a="http://schemas.openxmlformats.org/drawingml/2006/main">
               <a:ext uri="{FF2B5EF4-FFF2-40B4-BE49-F238E27FC236}">
-                <a16:creationId xmlns:a16="http://schemas.microsoft.com/office/drawing/2014/main" id="{22FBEAF6-2DBC-44C2-A51F-178DBA2F00FA}"/>
+                <a16:creationId xmlns:a16="http://schemas.microsoft.com/office/drawing/2014/main" id="{ED84DE53-1A8B-4FF6-8C68-3148B3F42091}"/>
               </a:ext>
             </a:extLst>
           </p:cNvPr>
@@ -13670,7 +13791,7 @@
           <p:cNvPr id="14" name="">
             <a:extLst xmlns:a="http://schemas.openxmlformats.org/drawingml/2006/main">
               <a:ext uri="{FF2B5EF4-FFF2-40B4-BE49-F238E27FC236}">
-                <a16:creationId xmlns:a16="http://schemas.microsoft.com/office/drawing/2014/main" id="{33D3945E-830E-44D0-A55D-25841020F935}"/>
+                <a16:creationId xmlns:a16="http://schemas.microsoft.com/office/drawing/2014/main" id="{072FD601-EE2E-48A0-BECD-18E70778552F}"/>
               </a:ext>
             </a:extLst>
           </p:cNvPr>
@@ -13701,7 +13822,7 @@
           <p:cNvPr id="15" name="">
             <a:extLst xmlns:a="http://schemas.openxmlformats.org/drawingml/2006/main">
               <a:ext uri="{FF2B5EF4-FFF2-40B4-BE49-F238E27FC236}">
-                <a16:creationId xmlns:a16="http://schemas.microsoft.com/office/drawing/2014/main" id="{2F741E2B-79C5-4C5F-B2E9-1923B0A9975A}"/>
+                <a16:creationId xmlns:a16="http://schemas.microsoft.com/office/drawing/2014/main" id="{600F9C22-264A-4B71-89A7-A85458774A91}"/>
               </a:ext>
             </a:extLst>
           </p:cNvPr>
@@ -13822,7 +13943,7 @@
           <p:cNvPr id="16" name="">
             <a:extLst xmlns:a="http://schemas.openxmlformats.org/drawingml/2006/main">
               <a:ext uri="{FF2B5EF4-FFF2-40B4-BE49-F238E27FC236}">
-                <a16:creationId xmlns:a16="http://schemas.microsoft.com/office/drawing/2014/main" id="{3C2EF74D-7A15-41BA-B6FB-6589B41796D3}"/>
+                <a16:creationId xmlns:a16="http://schemas.microsoft.com/office/drawing/2014/main" id="{FF9EB17D-CD4D-4DF2-8A40-BA176A770AAF}"/>
               </a:ext>
             </a:extLst>
           </p:cNvPr>
@@ -13941,7 +14062,7 @@
     </p:spTree>
     <p:extLst>
       <p:ext uri="{BB962C8B-B14F-4D97-AF65-F5344CB8AC3E}">
-        <p14:creationId xmlns:p14="http://schemas.microsoft.com/office/powerpoint/2010/main" val="2031779484"/>
+        <p14:creationId xmlns:p14="http://schemas.microsoft.com/office/powerpoint/2010/main" val="1758958294"/>
       </p:ext>
     </p:extLst>
   </p:cSld>
@@ -13972,7 +14093,7 @@
           <p:cNvPr id="17" name="">
             <a:extLst xmlns:a="http://schemas.openxmlformats.org/drawingml/2006/main">
               <a:ext uri="{FF2B5EF4-FFF2-40B4-BE49-F238E27FC236}">
-                <a16:creationId xmlns:a16="http://schemas.microsoft.com/office/drawing/2014/main" id="{81F374AC-9062-47D2-A40F-89611F8FE370}"/>
+                <a16:creationId xmlns:a16="http://schemas.microsoft.com/office/drawing/2014/main" id="{0CD8EC30-D66F-4536-9BA2-483FB1F53CB1}"/>
               </a:ext>
             </a:extLst>
           </p:cNvPr>
@@ -14003,7 +14124,7 @@
           <p:cNvPr id="2" name="">
             <a:extLst xmlns:a="http://schemas.openxmlformats.org/drawingml/2006/main">
               <a:ext uri="{FF2B5EF4-FFF2-40B4-BE49-F238E27FC236}">
-                <a16:creationId xmlns:a16="http://schemas.microsoft.com/office/drawing/2014/main" id="{6395EFF1-24D9-4400-B67A-686CA4DCB8FC}"/>
+                <a16:creationId xmlns:a16="http://schemas.microsoft.com/office/drawing/2014/main" id="{344DF543-2ADC-4EB6-926E-B7C4CBA3A0F9}"/>
               </a:ext>
             </a:extLst>
           </p:cNvPr>
@@ -14124,7 +14245,7 @@
           <p:cNvPr id="3" name="">
             <a:extLst xmlns:a="http://schemas.openxmlformats.org/drawingml/2006/main">
               <a:ext uri="{FF2B5EF4-FFF2-40B4-BE49-F238E27FC236}">
-                <a16:creationId xmlns:a16="http://schemas.microsoft.com/office/drawing/2014/main" id="{125BDFA8-1BAC-4412-8288-42C7FD261C19}"/>
+                <a16:creationId xmlns:a16="http://schemas.microsoft.com/office/drawing/2014/main" id="{6F984765-0E3A-4523-8F44-9E6AC819AB72}"/>
               </a:ext>
             </a:extLst>
           </p:cNvPr>
@@ -14245,7 +14366,7 @@
           <p:cNvPr id="4" name="">
             <a:extLst xmlns:a="http://schemas.openxmlformats.org/drawingml/2006/main">
               <a:ext uri="{FF2B5EF4-FFF2-40B4-BE49-F238E27FC236}">
-                <a16:creationId xmlns:a16="http://schemas.microsoft.com/office/drawing/2014/main" id="{D624E331-23C1-43B3-A154-2E8CD3D6A88C}"/>
+                <a16:creationId xmlns:a16="http://schemas.microsoft.com/office/drawing/2014/main" id="{21312CB1-8271-4108-B9F6-C6BD66F8A002}"/>
               </a:ext>
             </a:extLst>
           </p:cNvPr>
@@ -14366,7 +14487,7 @@
           <p:cNvPr id="5" name="">
             <a:extLst xmlns:a="http://schemas.openxmlformats.org/drawingml/2006/main">
               <a:ext uri="{FF2B5EF4-FFF2-40B4-BE49-F238E27FC236}">
-                <a16:creationId xmlns:a16="http://schemas.microsoft.com/office/drawing/2014/main" id="{EB785FD0-96CA-4DF0-B328-F13BB0FC9157}"/>
+                <a16:creationId xmlns:a16="http://schemas.microsoft.com/office/drawing/2014/main" id="{B13151DD-1028-4B20-8408-C427FAF5BCC3}"/>
               </a:ext>
             </a:extLst>
           </p:cNvPr>
@@ -14397,7 +14518,7 @@
           <p:cNvPr id="6" name="">
             <a:extLst xmlns:a="http://schemas.openxmlformats.org/drawingml/2006/main">
               <a:ext uri="{FF2B5EF4-FFF2-40B4-BE49-F238E27FC236}">
-                <a16:creationId xmlns:a16="http://schemas.microsoft.com/office/drawing/2014/main" id="{F27AC9ED-A51F-46E6-A125-CFAEEDEAD6E4}"/>
+                <a16:creationId xmlns:a16="http://schemas.microsoft.com/office/drawing/2014/main" id="{7148947B-8986-40DB-8EDB-6DEF67BC17AE}"/>
               </a:ext>
             </a:extLst>
           </p:cNvPr>
@@ -14518,7 +14639,7 @@
           <p:cNvPr id="7" name="">
             <a:extLst xmlns:a="http://schemas.openxmlformats.org/drawingml/2006/main">
               <a:ext uri="{FF2B5EF4-FFF2-40B4-BE49-F238E27FC236}">
-                <a16:creationId xmlns:a16="http://schemas.microsoft.com/office/drawing/2014/main" id="{E8F79AF4-15BE-4C55-BE10-2C9ACD4736B9}"/>
+                <a16:creationId xmlns:a16="http://schemas.microsoft.com/office/drawing/2014/main" id="{78857590-06EA-40D6-9B2D-34F60DAD6485}"/>
               </a:ext>
             </a:extLst>
           </p:cNvPr>
@@ -14528,7 +14649,7 @@
           <p:nvPr/>
         </p:nvPicPr>
         <p:blipFill>
-          <a:blip xmlns:r="http://schemas.openxmlformats.org/officeDocument/2006/relationships" xmlns:a="http://schemas.openxmlformats.org/drawingml/2006/main" r:embed="Rabec1c5d2fd44c2d"/>
+          <a:blip xmlns:r="http://schemas.openxmlformats.org/officeDocument/2006/relationships" xmlns:a="http://schemas.openxmlformats.org/drawingml/2006/main" r:embed="Rc129f5afc2f045c8"/>
           <a:stretch xmlns:a="http://schemas.openxmlformats.org/drawingml/2006/main"/>
         </p:blipFill>
         <p:spPr>
@@ -14546,7 +14667,7 @@
           <p:cNvPr id="8" name="">
             <a:extLst xmlns:a="http://schemas.openxmlformats.org/drawingml/2006/main">
               <a:ext uri="{FF2B5EF4-FFF2-40B4-BE49-F238E27FC236}">
-                <a16:creationId xmlns:a16="http://schemas.microsoft.com/office/drawing/2014/main" id="{10DD124E-F084-4098-9FBA-022D1E38FA31}"/>
+                <a16:creationId xmlns:a16="http://schemas.microsoft.com/office/drawing/2014/main" id="{B226785C-BCEC-4604-9963-87F570A6C9F9}"/>
               </a:ext>
             </a:extLst>
           </p:cNvPr>
@@ -14577,7 +14698,7 @@
           <p:cNvPr id="9" name="">
             <a:extLst xmlns:a="http://schemas.openxmlformats.org/drawingml/2006/main">
               <a:ext uri="{FF2B5EF4-FFF2-40B4-BE49-F238E27FC236}">
-                <a16:creationId xmlns:a16="http://schemas.microsoft.com/office/drawing/2014/main" id="{3AB71966-9111-4B15-929A-B72C090E5C2D}"/>
+                <a16:creationId xmlns:a16="http://schemas.microsoft.com/office/drawing/2014/main" id="{2FA1AA59-5C64-4356-AE50-DB02AE465CE2}"/>
               </a:ext>
             </a:extLst>
           </p:cNvPr>
@@ -14698,7 +14819,7 @@
           <p:cNvPr id="10" name="">
             <a:extLst xmlns:a="http://schemas.openxmlformats.org/drawingml/2006/main">
               <a:ext uri="{FF2B5EF4-FFF2-40B4-BE49-F238E27FC236}">
-                <a16:creationId xmlns:a16="http://schemas.microsoft.com/office/drawing/2014/main" id="{6DB70CCD-0D14-407B-A57D-77D38F01A56F}"/>
+                <a16:creationId xmlns:a16="http://schemas.microsoft.com/office/drawing/2014/main" id="{669F0AB8-CF5B-45FB-A36B-135BB31ABBBC}"/>
               </a:ext>
             </a:extLst>
           </p:cNvPr>
@@ -14819,7 +14940,7 @@
           <p:cNvPr id="11" name="">
             <a:extLst xmlns:a="http://schemas.openxmlformats.org/drawingml/2006/main">
               <a:ext uri="{FF2B5EF4-FFF2-40B4-BE49-F238E27FC236}">
-                <a16:creationId xmlns:a16="http://schemas.microsoft.com/office/drawing/2014/main" id="{09D922C4-9BE7-43DE-B24D-1C0603AAF37D}"/>
+                <a16:creationId xmlns:a16="http://schemas.microsoft.com/office/drawing/2014/main" id="{EE2D2C08-4AA5-4401-8B93-615045C07A8A}"/>
               </a:ext>
             </a:extLst>
           </p:cNvPr>
@@ -14850,7 +14971,7 @@
           <p:cNvPr id="12" name="">
             <a:extLst xmlns:a="http://schemas.openxmlformats.org/drawingml/2006/main">
               <a:ext uri="{FF2B5EF4-FFF2-40B4-BE49-F238E27FC236}">
-                <a16:creationId xmlns:a16="http://schemas.microsoft.com/office/drawing/2014/main" id="{D792B100-A152-4F33-AA3F-9FE20E899EFE}"/>
+                <a16:creationId xmlns:a16="http://schemas.microsoft.com/office/drawing/2014/main" id="{B3ADCE33-3386-4066-8BE1-1E9B48FD0214}"/>
               </a:ext>
             </a:extLst>
           </p:cNvPr>
@@ -14971,7 +15092,7 @@
           <p:cNvPr id="13" name="">
             <a:extLst xmlns:a="http://schemas.openxmlformats.org/drawingml/2006/main">
               <a:ext uri="{FF2B5EF4-FFF2-40B4-BE49-F238E27FC236}">
-                <a16:creationId xmlns:a16="http://schemas.microsoft.com/office/drawing/2014/main" id="{D11730B1-296A-4EAE-8C78-59FC71261F2C}"/>
+                <a16:creationId xmlns:a16="http://schemas.microsoft.com/office/drawing/2014/main" id="{972E108C-7D2D-4155-85C5-6F351370D6DC}"/>
               </a:ext>
             </a:extLst>
           </p:cNvPr>
@@ -15092,7 +15213,7 @@
           <p:cNvPr id="14" name="">
             <a:extLst xmlns:a="http://schemas.openxmlformats.org/drawingml/2006/main">
               <a:ext uri="{FF2B5EF4-FFF2-40B4-BE49-F238E27FC236}">
-                <a16:creationId xmlns:a16="http://schemas.microsoft.com/office/drawing/2014/main" id="{6BA3A16B-D92B-48B2-B864-3891020B31BE}"/>
+                <a16:creationId xmlns:a16="http://schemas.microsoft.com/office/drawing/2014/main" id="{D55BDA3E-EE3E-4C4F-98B2-AC9C46BE763B}"/>
               </a:ext>
             </a:extLst>
           </p:cNvPr>
@@ -15123,7 +15244,7 @@
           <p:cNvPr id="15" name="">
             <a:extLst xmlns:a="http://schemas.openxmlformats.org/drawingml/2006/main">
               <a:ext uri="{FF2B5EF4-FFF2-40B4-BE49-F238E27FC236}">
-                <a16:creationId xmlns:a16="http://schemas.microsoft.com/office/drawing/2014/main" id="{1E99938D-32F2-4367-B9CC-3EAB5825DFFC}"/>
+                <a16:creationId xmlns:a16="http://schemas.microsoft.com/office/drawing/2014/main" id="{ED167416-6B78-4076-B88F-E9279F8516AD}"/>
               </a:ext>
             </a:extLst>
           </p:cNvPr>
@@ -15244,7 +15365,7 @@
           <p:cNvPr id="16" name="">
             <a:extLst xmlns:a="http://schemas.openxmlformats.org/drawingml/2006/main">
               <a:ext uri="{FF2B5EF4-FFF2-40B4-BE49-F238E27FC236}">
-                <a16:creationId xmlns:a16="http://schemas.microsoft.com/office/drawing/2014/main" id="{73DD0718-BF48-490D-8A7E-AE165C44AE49}"/>
+                <a16:creationId xmlns:a16="http://schemas.microsoft.com/office/drawing/2014/main" id="{E05B4D84-4D68-45A5-B1AB-E521B8F654AB}"/>
               </a:ext>
             </a:extLst>
           </p:cNvPr>
@@ -15363,7 +15484,7 @@
     </p:spTree>
     <p:extLst>
       <p:ext uri="{BB962C8B-B14F-4D97-AF65-F5344CB8AC3E}">
-        <p14:creationId xmlns:p14="http://schemas.microsoft.com/office/powerpoint/2010/main" val="1792196204"/>
+        <p14:creationId xmlns:p14="http://schemas.microsoft.com/office/powerpoint/2010/main" val="735242707"/>
       </p:ext>
     </p:extLst>
   </p:cSld>
@@ -15394,7 +15515,7 @@
           <p:cNvPr id="17" name="">
             <a:extLst xmlns:a="http://schemas.openxmlformats.org/drawingml/2006/main">
               <a:ext uri="{FF2B5EF4-FFF2-40B4-BE49-F238E27FC236}">
-                <a16:creationId xmlns:a16="http://schemas.microsoft.com/office/drawing/2014/main" id="{F5A82D69-0399-4300-BFB4-3AE6B45C794F}"/>
+                <a16:creationId xmlns:a16="http://schemas.microsoft.com/office/drawing/2014/main" id="{7818ADA5-9A43-40F3-ABE7-BA1F77CD4F51}"/>
               </a:ext>
             </a:extLst>
           </p:cNvPr>
@@ -15425,7 +15546,7 @@
           <p:cNvPr id="2" name="">
             <a:extLst xmlns:a="http://schemas.openxmlformats.org/drawingml/2006/main">
               <a:ext uri="{FF2B5EF4-FFF2-40B4-BE49-F238E27FC236}">
-                <a16:creationId xmlns:a16="http://schemas.microsoft.com/office/drawing/2014/main" id="{BA4DBD0C-980A-4349-8580-ABB26CC73B69}"/>
+                <a16:creationId xmlns:a16="http://schemas.microsoft.com/office/drawing/2014/main" id="{ADFCE8CD-66B3-4435-B66B-65D82CBA253B}"/>
               </a:ext>
             </a:extLst>
           </p:cNvPr>
@@ -15546,7 +15667,7 @@
           <p:cNvPr id="3" name="">
             <a:extLst xmlns:a="http://schemas.openxmlformats.org/drawingml/2006/main">
               <a:ext uri="{FF2B5EF4-FFF2-40B4-BE49-F238E27FC236}">
-                <a16:creationId xmlns:a16="http://schemas.microsoft.com/office/drawing/2014/main" id="{F177487B-1798-41A1-985A-5AA54104D357}"/>
+                <a16:creationId xmlns:a16="http://schemas.microsoft.com/office/drawing/2014/main" id="{6FDAD4E2-75B1-480C-B09D-57F81F1C6734}"/>
               </a:ext>
             </a:extLst>
           </p:cNvPr>
@@ -15667,7 +15788,7 @@
           <p:cNvPr id="4" name="">
             <a:extLst xmlns:a="http://schemas.openxmlformats.org/drawingml/2006/main">
               <a:ext uri="{FF2B5EF4-FFF2-40B4-BE49-F238E27FC236}">
-                <a16:creationId xmlns:a16="http://schemas.microsoft.com/office/drawing/2014/main" id="{3FF6D8DE-653D-417D-A96C-917F1C444B6F}"/>
+                <a16:creationId xmlns:a16="http://schemas.microsoft.com/office/drawing/2014/main" id="{4B5CBD84-BE0C-4DB7-BCD3-E41478823DD1}"/>
               </a:ext>
             </a:extLst>
           </p:cNvPr>
@@ -15788,7 +15909,7 @@
           <p:cNvPr id="5" name="">
             <a:extLst xmlns:a="http://schemas.openxmlformats.org/drawingml/2006/main">
               <a:ext uri="{FF2B5EF4-FFF2-40B4-BE49-F238E27FC236}">
-                <a16:creationId xmlns:a16="http://schemas.microsoft.com/office/drawing/2014/main" id="{C3F2E94E-F388-47AF-99CD-D4F02EF8C76A}"/>
+                <a16:creationId xmlns:a16="http://schemas.microsoft.com/office/drawing/2014/main" id="{AC02E174-6AD2-4A43-820B-F63DF28F0FD3}"/>
               </a:ext>
             </a:extLst>
           </p:cNvPr>
@@ -15819,7 +15940,7 @@
           <p:cNvPr id="6" name="">
             <a:extLst xmlns:a="http://schemas.openxmlformats.org/drawingml/2006/main">
               <a:ext uri="{FF2B5EF4-FFF2-40B4-BE49-F238E27FC236}">
-                <a16:creationId xmlns:a16="http://schemas.microsoft.com/office/drawing/2014/main" id="{94462795-2394-43C3-B88F-F3515F290DFD}"/>
+                <a16:creationId xmlns:a16="http://schemas.microsoft.com/office/drawing/2014/main" id="{7FC7D168-C1F6-4EC4-B62F-F026F114A327}"/>
               </a:ext>
             </a:extLst>
           </p:cNvPr>
@@ -15940,7 +16061,7 @@
           <p:cNvPr id="7" name="">
             <a:extLst xmlns:a="http://schemas.openxmlformats.org/drawingml/2006/main">
               <a:ext uri="{FF2B5EF4-FFF2-40B4-BE49-F238E27FC236}">
-                <a16:creationId xmlns:a16="http://schemas.microsoft.com/office/drawing/2014/main" id="{F6B1CD46-29FE-4F9B-A2C6-A70A484884ED}"/>
+                <a16:creationId xmlns:a16="http://schemas.microsoft.com/office/drawing/2014/main" id="{68C1446B-976F-4A94-9D37-7E3F274E170A}"/>
               </a:ext>
             </a:extLst>
           </p:cNvPr>
@@ -15950,7 +16071,7 @@
           <p:nvPr/>
         </p:nvPicPr>
         <p:blipFill>
-          <a:blip xmlns:r="http://schemas.openxmlformats.org/officeDocument/2006/relationships" xmlns:a="http://schemas.openxmlformats.org/drawingml/2006/main" r:embed="Ra2402fc6602045be"/>
+          <a:blip xmlns:r="http://schemas.openxmlformats.org/officeDocument/2006/relationships" xmlns:a="http://schemas.openxmlformats.org/drawingml/2006/main" r:embed="Re92ce7cc047440c2"/>
           <a:stretch xmlns:a="http://schemas.openxmlformats.org/drawingml/2006/main"/>
         </p:blipFill>
         <p:spPr>
@@ -15968,7 +16089,7 @@
           <p:cNvPr id="8" name="">
             <a:extLst xmlns:a="http://schemas.openxmlformats.org/drawingml/2006/main">
               <a:ext uri="{FF2B5EF4-FFF2-40B4-BE49-F238E27FC236}">
-                <a16:creationId xmlns:a16="http://schemas.microsoft.com/office/drawing/2014/main" id="{D86ACC35-DC69-45FE-89BE-08B7D0BB280E}"/>
+                <a16:creationId xmlns:a16="http://schemas.microsoft.com/office/drawing/2014/main" id="{165A9FBD-8E80-40C3-8E0C-C7E51DFB0F20}"/>
               </a:ext>
             </a:extLst>
           </p:cNvPr>
@@ -15999,7 +16120,7 @@
           <p:cNvPr id="9" name="">
             <a:extLst xmlns:a="http://schemas.openxmlformats.org/drawingml/2006/main">
               <a:ext uri="{FF2B5EF4-FFF2-40B4-BE49-F238E27FC236}">
-                <a16:creationId xmlns:a16="http://schemas.microsoft.com/office/drawing/2014/main" id="{436F4993-257E-4AF0-AA12-BC595C5CF273}"/>
+                <a16:creationId xmlns:a16="http://schemas.microsoft.com/office/drawing/2014/main" id="{554BDD26-3842-44E4-A995-C7ADBF151096}"/>
               </a:ext>
             </a:extLst>
           </p:cNvPr>
@@ -16120,7 +16241,7 @@
           <p:cNvPr id="10" name="">
             <a:extLst xmlns:a="http://schemas.openxmlformats.org/drawingml/2006/main">
               <a:ext uri="{FF2B5EF4-FFF2-40B4-BE49-F238E27FC236}">
-                <a16:creationId xmlns:a16="http://schemas.microsoft.com/office/drawing/2014/main" id="{CAE0B987-546C-4B26-9D91-8E3880A78EC6}"/>
+                <a16:creationId xmlns:a16="http://schemas.microsoft.com/office/drawing/2014/main" id="{5A10BECB-B15D-4C97-B029-17E45F8BD579}"/>
               </a:ext>
             </a:extLst>
           </p:cNvPr>
@@ -16241,7 +16362,7 @@
           <p:cNvPr id="11" name="">
             <a:extLst xmlns:a="http://schemas.openxmlformats.org/drawingml/2006/main">
               <a:ext uri="{FF2B5EF4-FFF2-40B4-BE49-F238E27FC236}">
-                <a16:creationId xmlns:a16="http://schemas.microsoft.com/office/drawing/2014/main" id="{64A222F2-C82C-442C-9FB9-BDD49B0378FA}"/>
+                <a16:creationId xmlns:a16="http://schemas.microsoft.com/office/drawing/2014/main" id="{8292D1B4-EDBB-4C11-BDC1-EF7284D69137}"/>
               </a:ext>
             </a:extLst>
           </p:cNvPr>
@@ -16272,7 +16393,7 @@
           <p:cNvPr id="12" name="">
             <a:extLst xmlns:a="http://schemas.openxmlformats.org/drawingml/2006/main">
               <a:ext uri="{FF2B5EF4-FFF2-40B4-BE49-F238E27FC236}">
-                <a16:creationId xmlns:a16="http://schemas.microsoft.com/office/drawing/2014/main" id="{266D4263-F148-47B5-8828-2A0C49D5E251}"/>
+                <a16:creationId xmlns:a16="http://schemas.microsoft.com/office/drawing/2014/main" id="{57606C8C-4BC4-49AA-B702-17AEAE3758B2}"/>
               </a:ext>
             </a:extLst>
           </p:cNvPr>
@@ -16393,7 +16514,7 @@
           <p:cNvPr id="13" name="">
             <a:extLst xmlns:a="http://schemas.openxmlformats.org/drawingml/2006/main">
               <a:ext uri="{FF2B5EF4-FFF2-40B4-BE49-F238E27FC236}">
-                <a16:creationId xmlns:a16="http://schemas.microsoft.com/office/drawing/2014/main" id="{3C9C83E9-5131-471D-B0AA-73E557E5DB02}"/>
+                <a16:creationId xmlns:a16="http://schemas.microsoft.com/office/drawing/2014/main" id="{F88B70CF-6F21-47FE-B689-81ED6CE8871E}"/>
               </a:ext>
             </a:extLst>
           </p:cNvPr>
@@ -16514,7 +16635,7 @@
           <p:cNvPr id="14" name="">
             <a:extLst xmlns:a="http://schemas.openxmlformats.org/drawingml/2006/main">
               <a:ext uri="{FF2B5EF4-FFF2-40B4-BE49-F238E27FC236}">
-                <a16:creationId xmlns:a16="http://schemas.microsoft.com/office/drawing/2014/main" id="{BA7DAD51-3487-42FD-BB66-7F17E241B031}"/>
+                <a16:creationId xmlns:a16="http://schemas.microsoft.com/office/drawing/2014/main" id="{E708A0DA-AFD7-4865-949E-1A857E70B896}"/>
               </a:ext>
             </a:extLst>
           </p:cNvPr>
@@ -16545,7 +16666,7 @@
           <p:cNvPr id="15" name="">
             <a:extLst xmlns:a="http://schemas.openxmlformats.org/drawingml/2006/main">
               <a:ext uri="{FF2B5EF4-FFF2-40B4-BE49-F238E27FC236}">
-                <a16:creationId xmlns:a16="http://schemas.microsoft.com/office/drawing/2014/main" id="{D63674FA-B45D-46B3-968D-F1B50C86AA09}"/>
+                <a16:creationId xmlns:a16="http://schemas.microsoft.com/office/drawing/2014/main" id="{3413FD69-C010-4582-A148-DDF865513609}"/>
               </a:ext>
             </a:extLst>
           </p:cNvPr>
@@ -16666,7 +16787,7 @@
           <p:cNvPr id="16" name="">
             <a:extLst xmlns:a="http://schemas.openxmlformats.org/drawingml/2006/main">
               <a:ext uri="{FF2B5EF4-FFF2-40B4-BE49-F238E27FC236}">
-                <a16:creationId xmlns:a16="http://schemas.microsoft.com/office/drawing/2014/main" id="{35BC5B3F-DC8D-4931-AD50-A3E83F5D1856}"/>
+                <a16:creationId xmlns:a16="http://schemas.microsoft.com/office/drawing/2014/main" id="{8481AF21-5759-4F6C-9B2D-A1FDDEFD0AAC}"/>
               </a:ext>
             </a:extLst>
           </p:cNvPr>
@@ -16777,7 +16898,7 @@
                   <a:srgbClr val="5C6C70"/>
                 </a:solidFill>
               </a:rPr>
-              <a:t>RAW_ONLY 显示诊断，不伪装成功。</a:t>
+              <a:t>RAW_ONLY 保留原始流及诊断。</a:t>
             </a:r>
           </a:p>
         </p:txBody>
@@ -16785,7 +16906,7 @@
     </p:spTree>
     <p:extLst>
       <p:ext uri="{BB962C8B-B14F-4D97-AF65-F5344CB8AC3E}">
-        <p14:creationId xmlns:p14="http://schemas.microsoft.com/office/powerpoint/2010/main" val="61044768"/>
+        <p14:creationId xmlns:p14="http://schemas.microsoft.com/office/powerpoint/2010/main" val="1033813756"/>
       </p:ext>
     </p:extLst>
   </p:cSld>
@@ -16816,7 +16937,7 @@
           <p:cNvPr id="18" name="">
             <a:extLst xmlns:a="http://schemas.openxmlformats.org/drawingml/2006/main">
               <a:ext uri="{FF2B5EF4-FFF2-40B4-BE49-F238E27FC236}">
-                <a16:creationId xmlns:a16="http://schemas.microsoft.com/office/drawing/2014/main" id="{49838E2D-9FD1-4FC8-8C80-44BE53D45CBC}"/>
+                <a16:creationId xmlns:a16="http://schemas.microsoft.com/office/drawing/2014/main" id="{3DA7C0AF-2841-4273-B888-9F5B5873714C}"/>
               </a:ext>
             </a:extLst>
           </p:cNvPr>
@@ -16847,7 +16968,7 @@
           <p:cNvPr id="2" name="">
             <a:extLst xmlns:a="http://schemas.openxmlformats.org/drawingml/2006/main">
               <a:ext uri="{FF2B5EF4-FFF2-40B4-BE49-F238E27FC236}">
-                <a16:creationId xmlns:a16="http://schemas.microsoft.com/office/drawing/2014/main" id="{1526E064-FF3A-4946-BDC0-7F1FD14067AF}"/>
+                <a16:creationId xmlns:a16="http://schemas.microsoft.com/office/drawing/2014/main" id="{A525D586-426D-474B-923F-6CA8D7FFAADD}"/>
               </a:ext>
             </a:extLst>
           </p:cNvPr>
@@ -16968,7 +17089,7 @@
           <p:cNvPr id="3" name="">
             <a:extLst xmlns:a="http://schemas.openxmlformats.org/drawingml/2006/main">
               <a:ext uri="{FF2B5EF4-FFF2-40B4-BE49-F238E27FC236}">
-                <a16:creationId xmlns:a16="http://schemas.microsoft.com/office/drawing/2014/main" id="{7771FF22-92ED-497A-87E0-FC546C5D71C3}"/>
+                <a16:creationId xmlns:a16="http://schemas.microsoft.com/office/drawing/2014/main" id="{84A8C4DC-8506-4759-89AA-D52DAB7622DE}"/>
               </a:ext>
             </a:extLst>
           </p:cNvPr>
@@ -17089,7 +17210,7 @@
           <p:cNvPr id="4" name="">
             <a:extLst xmlns:a="http://schemas.openxmlformats.org/drawingml/2006/main">
               <a:ext uri="{FF2B5EF4-FFF2-40B4-BE49-F238E27FC236}">
-                <a16:creationId xmlns:a16="http://schemas.microsoft.com/office/drawing/2014/main" id="{8E148046-FCEA-4253-B5CF-3411B4D13EAD}"/>
+                <a16:creationId xmlns:a16="http://schemas.microsoft.com/office/drawing/2014/main" id="{FF187811-27CB-4EE1-BAE7-5B1B53DEBFAD}"/>
               </a:ext>
             </a:extLst>
           </p:cNvPr>
@@ -17210,7 +17331,7 @@
           <p:cNvPr id="5" name="">
             <a:extLst xmlns:a="http://schemas.openxmlformats.org/drawingml/2006/main">
               <a:ext uri="{FF2B5EF4-FFF2-40B4-BE49-F238E27FC236}">
-                <a16:creationId xmlns:a16="http://schemas.microsoft.com/office/drawing/2014/main" id="{3E50252D-6A4A-4A34-948C-F91401198365}"/>
+                <a16:creationId xmlns:a16="http://schemas.microsoft.com/office/drawing/2014/main" id="{BBD461D7-A455-4F91-A0AA-145CFDBF17FD}"/>
               </a:ext>
             </a:extLst>
           </p:cNvPr>
@@ -17241,7 +17362,7 @@
           <p:cNvPr id="6" name="">
             <a:extLst xmlns:a="http://schemas.openxmlformats.org/drawingml/2006/main">
               <a:ext uri="{FF2B5EF4-FFF2-40B4-BE49-F238E27FC236}">
-                <a16:creationId xmlns:a16="http://schemas.microsoft.com/office/drawing/2014/main" id="{7CC1F6E9-49FE-40F6-9948-DAD39FB095EB}"/>
+                <a16:creationId xmlns:a16="http://schemas.microsoft.com/office/drawing/2014/main" id="{07BBB2F3-7A41-4788-8AB9-AF45878154B2}"/>
               </a:ext>
             </a:extLst>
           </p:cNvPr>
@@ -17362,7 +17483,7 @@
           <p:cNvPr id="7" name="">
             <a:extLst xmlns:a="http://schemas.openxmlformats.org/drawingml/2006/main">
               <a:ext uri="{FF2B5EF4-FFF2-40B4-BE49-F238E27FC236}">
-                <a16:creationId xmlns:a16="http://schemas.microsoft.com/office/drawing/2014/main" id="{FED57FB7-A67F-4A6B-BD9A-8AC9BEDFD045}"/>
+                <a16:creationId xmlns:a16="http://schemas.microsoft.com/office/drawing/2014/main" id="{5F7C0309-408F-4447-9FE8-839E83104E20}"/>
               </a:ext>
             </a:extLst>
           </p:cNvPr>
@@ -17393,7 +17514,7 @@
           <p:cNvPr id="8" name="">
             <a:extLst xmlns:a="http://schemas.openxmlformats.org/drawingml/2006/main">
               <a:ext uri="{FF2B5EF4-FFF2-40B4-BE49-F238E27FC236}">
-                <a16:creationId xmlns:a16="http://schemas.microsoft.com/office/drawing/2014/main" id="{E7338A5F-FD58-4F00-B3B1-68F7A405B8B5}"/>
+                <a16:creationId xmlns:a16="http://schemas.microsoft.com/office/drawing/2014/main" id="{07CB9906-A8E7-4491-9420-6C34A02F7A43}"/>
               </a:ext>
             </a:extLst>
           </p:cNvPr>
@@ -17514,7 +17635,7 @@
           <p:cNvPr id="9" name="">
             <a:extLst xmlns:a="http://schemas.openxmlformats.org/drawingml/2006/main">
               <a:ext uri="{FF2B5EF4-FFF2-40B4-BE49-F238E27FC236}">
-                <a16:creationId xmlns:a16="http://schemas.microsoft.com/office/drawing/2014/main" id="{091FA876-4040-4DE0-92FD-D5AEF5B51961}"/>
+                <a16:creationId xmlns:a16="http://schemas.microsoft.com/office/drawing/2014/main" id="{722B4257-CD78-4B2B-BD7F-0C6F7CB454D3}"/>
               </a:ext>
             </a:extLst>
           </p:cNvPr>
@@ -17635,7 +17756,7 @@
           <p:cNvPr id="10" name="">
             <a:extLst xmlns:a="http://schemas.openxmlformats.org/drawingml/2006/main">
               <a:ext uri="{FF2B5EF4-FFF2-40B4-BE49-F238E27FC236}">
-                <a16:creationId xmlns:a16="http://schemas.microsoft.com/office/drawing/2014/main" id="{5E42FB9B-E533-411F-A475-7F80B0B72B8C}"/>
+                <a16:creationId xmlns:a16="http://schemas.microsoft.com/office/drawing/2014/main" id="{528A174D-F952-49CD-A5D5-ABB3FF16E066}"/>
               </a:ext>
             </a:extLst>
           </p:cNvPr>
@@ -17666,7 +17787,7 @@
           <p:cNvPr id="11" name="">
             <a:extLst xmlns:a="http://schemas.openxmlformats.org/drawingml/2006/main">
               <a:ext uri="{FF2B5EF4-FFF2-40B4-BE49-F238E27FC236}">
-                <a16:creationId xmlns:a16="http://schemas.microsoft.com/office/drawing/2014/main" id="{A2A741A9-B84B-4304-8D7A-6AA5EB36FACC}"/>
+                <a16:creationId xmlns:a16="http://schemas.microsoft.com/office/drawing/2014/main" id="{DCE62FF1-89CC-4ADF-9D43-EBD2E325B68B}"/>
               </a:ext>
             </a:extLst>
           </p:cNvPr>
@@ -17787,7 +17908,7 @@
           <p:cNvPr id="12" name="">
             <a:extLst xmlns:a="http://schemas.openxmlformats.org/drawingml/2006/main">
               <a:ext uri="{FF2B5EF4-FFF2-40B4-BE49-F238E27FC236}">
-                <a16:creationId xmlns:a16="http://schemas.microsoft.com/office/drawing/2014/main" id="{1D0CD380-4BC4-4C9A-9931-E1F92B6338C7}"/>
+                <a16:creationId xmlns:a16="http://schemas.microsoft.com/office/drawing/2014/main" id="{06F7802A-B35A-4E55-A417-D0BB4CE88702}"/>
               </a:ext>
             </a:extLst>
           </p:cNvPr>
@@ -17908,7 +18029,7 @@
           <p:cNvPr id="13" name="">
             <a:extLst xmlns:a="http://schemas.openxmlformats.org/drawingml/2006/main">
               <a:ext uri="{FF2B5EF4-FFF2-40B4-BE49-F238E27FC236}">
-                <a16:creationId xmlns:a16="http://schemas.microsoft.com/office/drawing/2014/main" id="{F0A28500-72B5-4774-8EF1-397FD334D420}"/>
+                <a16:creationId xmlns:a16="http://schemas.microsoft.com/office/drawing/2014/main" id="{00B721B9-3A8B-4F40-A0AF-42993F1A0F5F}"/>
               </a:ext>
             </a:extLst>
           </p:cNvPr>
@@ -17939,7 +18060,7 @@
           <p:cNvPr id="14" name="">
             <a:extLst xmlns:a="http://schemas.openxmlformats.org/drawingml/2006/main">
               <a:ext uri="{FF2B5EF4-FFF2-40B4-BE49-F238E27FC236}">
-                <a16:creationId xmlns:a16="http://schemas.microsoft.com/office/drawing/2014/main" id="{DBEE9880-2360-4BA8-BC43-CE1E6F7951CC}"/>
+                <a16:creationId xmlns:a16="http://schemas.microsoft.com/office/drawing/2014/main" id="{7A6A6BAC-9151-4870-86E4-0EBA2C21E2D8}"/>
               </a:ext>
             </a:extLst>
           </p:cNvPr>
@@ -18060,7 +18181,7 @@
           <p:cNvPr id="15" name="">
             <a:extLst xmlns:a="http://schemas.openxmlformats.org/drawingml/2006/main">
               <a:ext uri="{FF2B5EF4-FFF2-40B4-BE49-F238E27FC236}">
-                <a16:creationId xmlns:a16="http://schemas.microsoft.com/office/drawing/2014/main" id="{0FA9AE53-849D-4B54-8502-6A82F2651CF7}"/>
+                <a16:creationId xmlns:a16="http://schemas.microsoft.com/office/drawing/2014/main" id="{6C231E95-F977-4974-B523-45A59870266A}"/>
               </a:ext>
             </a:extLst>
           </p:cNvPr>
@@ -18181,7 +18302,7 @@
           <p:cNvPr id="16" name="">
             <a:extLst xmlns:a="http://schemas.openxmlformats.org/drawingml/2006/main">
               <a:ext uri="{FF2B5EF4-FFF2-40B4-BE49-F238E27FC236}">
-                <a16:creationId xmlns:a16="http://schemas.microsoft.com/office/drawing/2014/main" id="{1598AF56-45BC-459D-95F2-180297DA03ED}"/>
+                <a16:creationId xmlns:a16="http://schemas.microsoft.com/office/drawing/2014/main" id="{93E7E8CF-62B8-4E46-A9EE-4CF1E9F6221B}"/>
               </a:ext>
             </a:extLst>
           </p:cNvPr>
@@ -18214,7 +18335,7 @@
           <p:cNvPr id="17" name="">
             <a:extLst xmlns:a="http://schemas.openxmlformats.org/drawingml/2006/main">
               <a:ext uri="{FF2B5EF4-FFF2-40B4-BE49-F238E27FC236}">
-                <a16:creationId xmlns:a16="http://schemas.microsoft.com/office/drawing/2014/main" id="{3A15A0BA-FCD1-4065-B3C7-6CEBB5A75D7A}"/>
+                <a16:creationId xmlns:a16="http://schemas.microsoft.com/office/drawing/2014/main" id="{24B34162-83AA-4542-A670-35068319EDED}"/>
               </a:ext>
             </a:extLst>
           </p:cNvPr>
@@ -18333,7 +18454,7 @@
     </p:spTree>
     <p:extLst>
       <p:ext uri="{BB962C8B-B14F-4D97-AF65-F5344CB8AC3E}">
-        <p14:creationId xmlns:p14="http://schemas.microsoft.com/office/powerpoint/2010/main" val="47261911"/>
+        <p14:creationId xmlns:p14="http://schemas.microsoft.com/office/powerpoint/2010/main" val="291763470"/>
       </p:ext>
     </p:extLst>
   </p:cSld>
@@ -18364,7 +18485,7 @@
           <p:cNvPr id="17" name="">
             <a:extLst xmlns:a="http://schemas.openxmlformats.org/drawingml/2006/main">
               <a:ext uri="{FF2B5EF4-FFF2-40B4-BE49-F238E27FC236}">
-                <a16:creationId xmlns:a16="http://schemas.microsoft.com/office/drawing/2014/main" id="{5D79DDF7-6738-4731-A5A7-3E383B6BF7F3}"/>
+                <a16:creationId xmlns:a16="http://schemas.microsoft.com/office/drawing/2014/main" id="{0FABA8CF-73A8-428F-9458-33C27FF6587E}"/>
               </a:ext>
             </a:extLst>
           </p:cNvPr>
@@ -18395,7 +18516,7 @@
           <p:cNvPr id="2" name="">
             <a:extLst xmlns:a="http://schemas.openxmlformats.org/drawingml/2006/main">
               <a:ext uri="{FF2B5EF4-FFF2-40B4-BE49-F238E27FC236}">
-                <a16:creationId xmlns:a16="http://schemas.microsoft.com/office/drawing/2014/main" id="{8218604A-1979-417D-8BB3-C1BA8C569D23}"/>
+                <a16:creationId xmlns:a16="http://schemas.microsoft.com/office/drawing/2014/main" id="{9AF7DF44-6DB0-4F3E-8DDA-C6D473350CD1}"/>
               </a:ext>
             </a:extLst>
           </p:cNvPr>
@@ -18516,7 +18637,7 @@
           <p:cNvPr id="3" name="">
             <a:extLst xmlns:a="http://schemas.openxmlformats.org/drawingml/2006/main">
               <a:ext uri="{FF2B5EF4-FFF2-40B4-BE49-F238E27FC236}">
-                <a16:creationId xmlns:a16="http://schemas.microsoft.com/office/drawing/2014/main" id="{17AD59C1-697C-43C3-80AD-DCF4E9B35092}"/>
+                <a16:creationId xmlns:a16="http://schemas.microsoft.com/office/drawing/2014/main" id="{87CD18EB-FA4E-4A86-9957-00DFEEC69181}"/>
               </a:ext>
             </a:extLst>
           </p:cNvPr>
@@ -18637,7 +18758,7 @@
           <p:cNvPr id="4" name="">
             <a:extLst xmlns:a="http://schemas.openxmlformats.org/drawingml/2006/main">
               <a:ext uri="{FF2B5EF4-FFF2-40B4-BE49-F238E27FC236}">
-                <a16:creationId xmlns:a16="http://schemas.microsoft.com/office/drawing/2014/main" id="{DEFCAF4A-E24F-499E-940F-F27189B93827}"/>
+                <a16:creationId xmlns:a16="http://schemas.microsoft.com/office/drawing/2014/main" id="{A2887450-8E1E-4793-BA3E-F87CE783138C}"/>
               </a:ext>
             </a:extLst>
           </p:cNvPr>
@@ -18758,7 +18879,7 @@
           <p:cNvPr id="5" name="">
             <a:extLst xmlns:a="http://schemas.openxmlformats.org/drawingml/2006/main">
               <a:ext uri="{FF2B5EF4-FFF2-40B4-BE49-F238E27FC236}">
-                <a16:creationId xmlns:a16="http://schemas.microsoft.com/office/drawing/2014/main" id="{38596142-BB19-4F50-84B8-F4A9AF7F47E3}"/>
+                <a16:creationId xmlns:a16="http://schemas.microsoft.com/office/drawing/2014/main" id="{CC259B89-32E8-4FA7-A2E9-5EED39D26723}"/>
               </a:ext>
             </a:extLst>
           </p:cNvPr>
@@ -18789,7 +18910,7 @@
           <p:cNvPr id="6" name="">
             <a:extLst xmlns:a="http://schemas.openxmlformats.org/drawingml/2006/main">
               <a:ext uri="{FF2B5EF4-FFF2-40B4-BE49-F238E27FC236}">
-                <a16:creationId xmlns:a16="http://schemas.microsoft.com/office/drawing/2014/main" id="{619B66AE-2452-4614-B64A-AB39C19AB2AE}"/>
+                <a16:creationId xmlns:a16="http://schemas.microsoft.com/office/drawing/2014/main" id="{D5A79B2F-AB07-4421-9FDF-F4C7C65D9ED5}"/>
               </a:ext>
             </a:extLst>
           </p:cNvPr>
@@ -18910,7 +19031,7 @@
           <p:cNvPr id="7" name="">
             <a:extLst xmlns:a="http://schemas.openxmlformats.org/drawingml/2006/main">
               <a:ext uri="{FF2B5EF4-FFF2-40B4-BE49-F238E27FC236}">
-                <a16:creationId xmlns:a16="http://schemas.microsoft.com/office/drawing/2014/main" id="{8F4B5304-D40E-41CE-8C13-6287C7C1A3A9}"/>
+                <a16:creationId xmlns:a16="http://schemas.microsoft.com/office/drawing/2014/main" id="{E69A1434-A860-4329-B2B7-8EC64B4100F4}"/>
               </a:ext>
             </a:extLst>
           </p:cNvPr>
@@ -18920,7 +19041,7 @@
           <p:nvPr/>
         </p:nvPicPr>
         <p:blipFill>
-          <a:blip xmlns:r="http://schemas.openxmlformats.org/officeDocument/2006/relationships" xmlns:a="http://schemas.openxmlformats.org/drawingml/2006/main" r:embed="Rc80969a552314428"/>
+          <a:blip xmlns:r="http://schemas.openxmlformats.org/officeDocument/2006/relationships" xmlns:a="http://schemas.openxmlformats.org/drawingml/2006/main" r:embed="R27d17b6d03074ae3"/>
           <a:stretch xmlns:a="http://schemas.openxmlformats.org/drawingml/2006/main"/>
         </p:blipFill>
         <p:spPr>
@@ -18938,7 +19059,7 @@
           <p:cNvPr id="8" name="">
             <a:extLst xmlns:a="http://schemas.openxmlformats.org/drawingml/2006/main">
               <a:ext uri="{FF2B5EF4-FFF2-40B4-BE49-F238E27FC236}">
-                <a16:creationId xmlns:a16="http://schemas.microsoft.com/office/drawing/2014/main" id="{E295099E-9EB1-4F72-9593-A41D5FEBF198}"/>
+                <a16:creationId xmlns:a16="http://schemas.microsoft.com/office/drawing/2014/main" id="{BE8DF687-9301-4484-A259-9645DEA20F40}"/>
               </a:ext>
             </a:extLst>
           </p:cNvPr>
@@ -18969,7 +19090,7 @@
           <p:cNvPr id="9" name="">
             <a:extLst xmlns:a="http://schemas.openxmlformats.org/drawingml/2006/main">
               <a:ext uri="{FF2B5EF4-FFF2-40B4-BE49-F238E27FC236}">
-                <a16:creationId xmlns:a16="http://schemas.microsoft.com/office/drawing/2014/main" id="{6C8874B0-08F2-47FC-927C-DCD5EB81FC0D}"/>
+                <a16:creationId xmlns:a16="http://schemas.microsoft.com/office/drawing/2014/main" id="{33B9B2D2-83E4-4118-BDFC-BEA86C2A864E}"/>
               </a:ext>
             </a:extLst>
           </p:cNvPr>
@@ -19090,7 +19211,7 @@
           <p:cNvPr id="10" name="">
             <a:extLst xmlns:a="http://schemas.openxmlformats.org/drawingml/2006/main">
               <a:ext uri="{FF2B5EF4-FFF2-40B4-BE49-F238E27FC236}">
-                <a16:creationId xmlns:a16="http://schemas.microsoft.com/office/drawing/2014/main" id="{65EDE420-CCCB-49D7-89B1-92047F001DE8}"/>
+                <a16:creationId xmlns:a16="http://schemas.microsoft.com/office/drawing/2014/main" id="{6D1FD15E-015D-45D7-AA5F-B9DFAC1CDEC1}"/>
               </a:ext>
             </a:extLst>
           </p:cNvPr>
@@ -19211,7 +19332,7 @@
           <p:cNvPr id="11" name="">
             <a:extLst xmlns:a="http://schemas.openxmlformats.org/drawingml/2006/main">
               <a:ext uri="{FF2B5EF4-FFF2-40B4-BE49-F238E27FC236}">
-                <a16:creationId xmlns:a16="http://schemas.microsoft.com/office/drawing/2014/main" id="{08EE591B-5A2B-4DF7-8C4E-23D13AD87782}"/>
+                <a16:creationId xmlns:a16="http://schemas.microsoft.com/office/drawing/2014/main" id="{F52E4B9A-4346-4A6E-905C-E858B1668E76}"/>
               </a:ext>
             </a:extLst>
           </p:cNvPr>
@@ -19242,7 +19363,7 @@
           <p:cNvPr id="12" name="">
             <a:extLst xmlns:a="http://schemas.openxmlformats.org/drawingml/2006/main">
               <a:ext uri="{FF2B5EF4-FFF2-40B4-BE49-F238E27FC236}">
-                <a16:creationId xmlns:a16="http://schemas.microsoft.com/office/drawing/2014/main" id="{FD5DEB44-E42A-43FD-A13E-AB9F69132B8D}"/>
+                <a16:creationId xmlns:a16="http://schemas.microsoft.com/office/drawing/2014/main" id="{6CE98A64-4043-4F3E-9EB8-18C1055728E0}"/>
               </a:ext>
             </a:extLst>
           </p:cNvPr>
@@ -19363,7 +19484,7 @@
           <p:cNvPr id="13" name="">
             <a:extLst xmlns:a="http://schemas.openxmlformats.org/drawingml/2006/main">
               <a:ext uri="{FF2B5EF4-FFF2-40B4-BE49-F238E27FC236}">
-                <a16:creationId xmlns:a16="http://schemas.microsoft.com/office/drawing/2014/main" id="{75452AC6-1CB6-46F7-8E23-072FFB972302}"/>
+                <a16:creationId xmlns:a16="http://schemas.microsoft.com/office/drawing/2014/main" id="{26CA5E23-182C-4EE1-BB2F-2464FC508F0A}"/>
               </a:ext>
             </a:extLst>
           </p:cNvPr>
@@ -19484,7 +19605,7 @@
           <p:cNvPr id="14" name="">
             <a:extLst xmlns:a="http://schemas.openxmlformats.org/drawingml/2006/main">
               <a:ext uri="{FF2B5EF4-FFF2-40B4-BE49-F238E27FC236}">
-                <a16:creationId xmlns:a16="http://schemas.microsoft.com/office/drawing/2014/main" id="{94987E6B-A387-4BB8-8F58-381B1F0CDCC5}"/>
+                <a16:creationId xmlns:a16="http://schemas.microsoft.com/office/drawing/2014/main" id="{454C9BD7-DF78-40B8-9F5A-8B39AEC0665B}"/>
               </a:ext>
             </a:extLst>
           </p:cNvPr>
@@ -19515,7 +19636,7 @@
           <p:cNvPr id="15" name="">
             <a:extLst xmlns:a="http://schemas.openxmlformats.org/drawingml/2006/main">
               <a:ext uri="{FF2B5EF4-FFF2-40B4-BE49-F238E27FC236}">
-                <a16:creationId xmlns:a16="http://schemas.microsoft.com/office/drawing/2014/main" id="{73128E4D-58E9-4AED-8931-A0F2F4D59AF5}"/>
+                <a16:creationId xmlns:a16="http://schemas.microsoft.com/office/drawing/2014/main" id="{3D053056-980B-45A1-9229-31A09E83BFCA}"/>
               </a:ext>
             </a:extLst>
           </p:cNvPr>
@@ -19636,7 +19757,7 @@
           <p:cNvPr id="16" name="">
             <a:extLst xmlns:a="http://schemas.openxmlformats.org/drawingml/2006/main">
               <a:ext uri="{FF2B5EF4-FFF2-40B4-BE49-F238E27FC236}">
-                <a16:creationId xmlns:a16="http://schemas.microsoft.com/office/drawing/2014/main" id="{F3C23137-C379-4747-81F7-AE3EE78DBA5D}"/>
+                <a16:creationId xmlns:a16="http://schemas.microsoft.com/office/drawing/2014/main" id="{87737F4A-9F91-444C-A33F-E40C6E8B5E6D}"/>
               </a:ext>
             </a:extLst>
           </p:cNvPr>
@@ -19755,7 +19876,7 @@
     </p:spTree>
     <p:extLst>
       <p:ext uri="{BB962C8B-B14F-4D97-AF65-F5344CB8AC3E}">
-        <p14:creationId xmlns:p14="http://schemas.microsoft.com/office/powerpoint/2010/main" val="1816432089"/>
+        <p14:creationId xmlns:p14="http://schemas.microsoft.com/office/powerpoint/2010/main" val="927181879"/>
       </p:ext>
     </p:extLst>
   </p:cSld>
@@ -19786,7 +19907,7 @@
           <p:cNvPr id="17" name="">
             <a:extLst xmlns:a="http://schemas.openxmlformats.org/drawingml/2006/main">
               <a:ext uri="{FF2B5EF4-FFF2-40B4-BE49-F238E27FC236}">
-                <a16:creationId xmlns:a16="http://schemas.microsoft.com/office/drawing/2014/main" id="{2738C08F-19A4-4A23-BA03-02E7992EC091}"/>
+                <a16:creationId xmlns:a16="http://schemas.microsoft.com/office/drawing/2014/main" id="{6D927D25-2477-489C-8FE6-AAC22BA03D5F}"/>
               </a:ext>
             </a:extLst>
           </p:cNvPr>
@@ -19817,7 +19938,7 @@
           <p:cNvPr id="2" name="">
             <a:extLst xmlns:a="http://schemas.openxmlformats.org/drawingml/2006/main">
               <a:ext uri="{FF2B5EF4-FFF2-40B4-BE49-F238E27FC236}">
-                <a16:creationId xmlns:a16="http://schemas.microsoft.com/office/drawing/2014/main" id="{56E425C0-3219-4F37-99D3-7E0D53D38030}"/>
+                <a16:creationId xmlns:a16="http://schemas.microsoft.com/office/drawing/2014/main" id="{1E3D421F-34D7-4C20-91F2-8DF0F9386074}"/>
               </a:ext>
             </a:extLst>
           </p:cNvPr>
@@ -19938,7 +20059,7 @@
           <p:cNvPr id="3" name="">
             <a:extLst xmlns:a="http://schemas.openxmlformats.org/drawingml/2006/main">
               <a:ext uri="{FF2B5EF4-FFF2-40B4-BE49-F238E27FC236}">
-                <a16:creationId xmlns:a16="http://schemas.microsoft.com/office/drawing/2014/main" id="{7E214BAD-71B4-42C3-A9CC-A621CFC697DA}"/>
+                <a16:creationId xmlns:a16="http://schemas.microsoft.com/office/drawing/2014/main" id="{E17D95B1-B3A3-45CC-A4CC-C86F76F9B1C8}"/>
               </a:ext>
             </a:extLst>
           </p:cNvPr>
@@ -20059,7 +20180,7 @@
           <p:cNvPr id="4" name="">
             <a:extLst xmlns:a="http://schemas.openxmlformats.org/drawingml/2006/main">
               <a:ext uri="{FF2B5EF4-FFF2-40B4-BE49-F238E27FC236}">
-                <a16:creationId xmlns:a16="http://schemas.microsoft.com/office/drawing/2014/main" id="{8432BC04-D1D7-4E54-B81C-D914C8444779}"/>
+                <a16:creationId xmlns:a16="http://schemas.microsoft.com/office/drawing/2014/main" id="{17F8234C-2974-44D8-9E4E-0F52967F4D9F}"/>
               </a:ext>
             </a:extLst>
           </p:cNvPr>
@@ -20180,7 +20301,7 @@
           <p:cNvPr id="5" name="">
             <a:extLst xmlns:a="http://schemas.openxmlformats.org/drawingml/2006/main">
               <a:ext uri="{FF2B5EF4-FFF2-40B4-BE49-F238E27FC236}">
-                <a16:creationId xmlns:a16="http://schemas.microsoft.com/office/drawing/2014/main" id="{2C7F5959-E218-42A1-B575-15B8EDF5917A}"/>
+                <a16:creationId xmlns:a16="http://schemas.microsoft.com/office/drawing/2014/main" id="{51D3EFCC-66F8-43C2-9097-E7544D54F655}"/>
               </a:ext>
             </a:extLst>
           </p:cNvPr>
@@ -20211,7 +20332,7 @@
           <p:cNvPr id="6" name="">
             <a:extLst xmlns:a="http://schemas.openxmlformats.org/drawingml/2006/main">
               <a:ext uri="{FF2B5EF4-FFF2-40B4-BE49-F238E27FC236}">
-                <a16:creationId xmlns:a16="http://schemas.microsoft.com/office/drawing/2014/main" id="{BFD12C0B-2C23-4599-8818-E8496B510F4E}"/>
+                <a16:creationId xmlns:a16="http://schemas.microsoft.com/office/drawing/2014/main" id="{D6C99921-4A66-4BDB-829A-6A9ACA2750A3}"/>
               </a:ext>
             </a:extLst>
           </p:cNvPr>
@@ -20332,7 +20453,7 @@
           <p:cNvPr id="7" name="">
             <a:extLst xmlns:a="http://schemas.openxmlformats.org/drawingml/2006/main">
               <a:ext uri="{FF2B5EF4-FFF2-40B4-BE49-F238E27FC236}">
-                <a16:creationId xmlns:a16="http://schemas.microsoft.com/office/drawing/2014/main" id="{53AD3291-B9F4-40FC-9AB5-6EC52D619978}"/>
+                <a16:creationId xmlns:a16="http://schemas.microsoft.com/office/drawing/2014/main" id="{B310E222-1F00-4E33-AB02-05F9A7F6C6EF}"/>
               </a:ext>
             </a:extLst>
           </p:cNvPr>
@@ -20342,7 +20463,7 @@
           <p:nvPr/>
         </p:nvPicPr>
         <p:blipFill>
-          <a:blip xmlns:r="http://schemas.openxmlformats.org/officeDocument/2006/relationships" xmlns:a="http://schemas.openxmlformats.org/drawingml/2006/main" r:embed="Rae55ed608e5e4fc0"/>
+          <a:blip xmlns:r="http://schemas.openxmlformats.org/officeDocument/2006/relationships" xmlns:a="http://schemas.openxmlformats.org/drawingml/2006/main" r:embed="Rfea4221d12cc47cc"/>
           <a:stretch xmlns:a="http://schemas.openxmlformats.org/drawingml/2006/main"/>
         </p:blipFill>
         <p:spPr>
@@ -20360,7 +20481,7 @@
           <p:cNvPr id="8" name="">
             <a:extLst xmlns:a="http://schemas.openxmlformats.org/drawingml/2006/main">
               <a:ext uri="{FF2B5EF4-FFF2-40B4-BE49-F238E27FC236}">
-                <a16:creationId xmlns:a16="http://schemas.microsoft.com/office/drawing/2014/main" id="{6DFDFC6C-337B-4AAA-BC24-AEE150568C96}"/>
+                <a16:creationId xmlns:a16="http://schemas.microsoft.com/office/drawing/2014/main" id="{CE1F9B0F-FD64-422C-AA89-607F4D5CD473}"/>
               </a:ext>
             </a:extLst>
           </p:cNvPr>
@@ -20391,7 +20512,7 @@
           <p:cNvPr id="9" name="">
             <a:extLst xmlns:a="http://schemas.openxmlformats.org/drawingml/2006/main">
               <a:ext uri="{FF2B5EF4-FFF2-40B4-BE49-F238E27FC236}">
-                <a16:creationId xmlns:a16="http://schemas.microsoft.com/office/drawing/2014/main" id="{F66C5831-F153-4743-AB5D-E72756F83867}"/>
+                <a16:creationId xmlns:a16="http://schemas.microsoft.com/office/drawing/2014/main" id="{21C63177-AB30-4927-8C2E-E335B94B8EA7}"/>
               </a:ext>
             </a:extLst>
           </p:cNvPr>
@@ -20512,7 +20633,7 @@
           <p:cNvPr id="10" name="">
             <a:extLst xmlns:a="http://schemas.openxmlformats.org/drawingml/2006/main">
               <a:ext uri="{FF2B5EF4-FFF2-40B4-BE49-F238E27FC236}">
-                <a16:creationId xmlns:a16="http://schemas.microsoft.com/office/drawing/2014/main" id="{35C290AF-F290-4E5A-A9C8-64465CF740EF}"/>
+                <a16:creationId xmlns:a16="http://schemas.microsoft.com/office/drawing/2014/main" id="{6B16BA5A-D398-4B61-9D6C-C8CF91958CA3}"/>
               </a:ext>
             </a:extLst>
           </p:cNvPr>
@@ -20633,7 +20754,7 @@
           <p:cNvPr id="11" name="">
             <a:extLst xmlns:a="http://schemas.openxmlformats.org/drawingml/2006/main">
               <a:ext uri="{FF2B5EF4-FFF2-40B4-BE49-F238E27FC236}">
-                <a16:creationId xmlns:a16="http://schemas.microsoft.com/office/drawing/2014/main" id="{3B390B62-E705-4E14-93EA-F2496AFE134A}"/>
+                <a16:creationId xmlns:a16="http://schemas.microsoft.com/office/drawing/2014/main" id="{DECC0074-CDD8-49FE-BB82-8CEC87F3E651}"/>
               </a:ext>
             </a:extLst>
           </p:cNvPr>
@@ -20664,7 +20785,7 @@
           <p:cNvPr id="12" name="">
             <a:extLst xmlns:a="http://schemas.openxmlformats.org/drawingml/2006/main">
               <a:ext uri="{FF2B5EF4-FFF2-40B4-BE49-F238E27FC236}">
-                <a16:creationId xmlns:a16="http://schemas.microsoft.com/office/drawing/2014/main" id="{3BF81B3E-0109-456A-B56A-6BC27A130B9D}"/>
+                <a16:creationId xmlns:a16="http://schemas.microsoft.com/office/drawing/2014/main" id="{41864B7B-9695-4A5F-9C2E-2149D3AE4500}"/>
               </a:ext>
             </a:extLst>
           </p:cNvPr>
@@ -20785,7 +20906,7 @@
           <p:cNvPr id="13" name="">
             <a:extLst xmlns:a="http://schemas.openxmlformats.org/drawingml/2006/main">
               <a:ext uri="{FF2B5EF4-FFF2-40B4-BE49-F238E27FC236}">
-                <a16:creationId xmlns:a16="http://schemas.microsoft.com/office/drawing/2014/main" id="{2A10E730-C652-4B73-8788-BB543929A1FE}"/>
+                <a16:creationId xmlns:a16="http://schemas.microsoft.com/office/drawing/2014/main" id="{9FDB569F-AC7A-4DA7-A23F-6E3D6C2ACC38}"/>
               </a:ext>
             </a:extLst>
           </p:cNvPr>
@@ -20906,7 +21027,7 @@
           <p:cNvPr id="14" name="">
             <a:extLst xmlns:a="http://schemas.openxmlformats.org/drawingml/2006/main">
               <a:ext uri="{FF2B5EF4-FFF2-40B4-BE49-F238E27FC236}">
-                <a16:creationId xmlns:a16="http://schemas.microsoft.com/office/drawing/2014/main" id="{6B7E7BAB-541A-4E09-93ED-F9B0E9999A1E}"/>
+                <a16:creationId xmlns:a16="http://schemas.microsoft.com/office/drawing/2014/main" id="{DD852E20-6EE3-4075-AAE8-9B0756CA9CCC}"/>
               </a:ext>
             </a:extLst>
           </p:cNvPr>
@@ -20937,7 +21058,7 @@
           <p:cNvPr id="15" name="">
             <a:extLst xmlns:a="http://schemas.openxmlformats.org/drawingml/2006/main">
               <a:ext uri="{FF2B5EF4-FFF2-40B4-BE49-F238E27FC236}">
-                <a16:creationId xmlns:a16="http://schemas.microsoft.com/office/drawing/2014/main" id="{CB6BE8A8-CC97-40DF-8F21-BDC6B677D119}"/>
+                <a16:creationId xmlns:a16="http://schemas.microsoft.com/office/drawing/2014/main" id="{12AFDFC4-1EC8-473D-93B6-190CC7149A94}"/>
               </a:ext>
             </a:extLst>
           </p:cNvPr>
@@ -21058,7 +21179,7 @@
           <p:cNvPr id="16" name="">
             <a:extLst xmlns:a="http://schemas.openxmlformats.org/drawingml/2006/main">
               <a:ext uri="{FF2B5EF4-FFF2-40B4-BE49-F238E27FC236}">
-                <a16:creationId xmlns:a16="http://schemas.microsoft.com/office/drawing/2014/main" id="{FEBC3F8E-D538-453A-9A4B-A7FC16CE6B58}"/>
+                <a16:creationId xmlns:a16="http://schemas.microsoft.com/office/drawing/2014/main" id="{870AE28E-A0DF-449C-94BB-47D31C321677}"/>
               </a:ext>
             </a:extLst>
           </p:cNvPr>
@@ -21177,7 +21298,7 @@
     </p:spTree>
     <p:extLst>
       <p:ext uri="{BB962C8B-B14F-4D97-AF65-F5344CB8AC3E}">
-        <p14:creationId xmlns:p14="http://schemas.microsoft.com/office/powerpoint/2010/main" val="1491440492"/>
+        <p14:creationId xmlns:p14="http://schemas.microsoft.com/office/powerpoint/2010/main" val="900476454"/>
       </p:ext>
     </p:extLst>
   </p:cSld>

</xml_diff>